<commit_message>
docs: update final presentation slides with latest research findings
</commit_message>
<xml_diff>
--- a/SER_Final_Presentation.pptx
+++ b/SER_Final_Presentation.pptx
@@ -257,7 +257,7 @@
   </p:defaultTextStyle>
   <p:extLst>
     <p:ext uri="GoogleSlidesCustomDataVersion2">
-      <go:slidesCustomData xmlns:go="http://customooxmlschemas.google.com/" r:id="rId20" roundtripDataSignature="AMtx7mjhGg5ALly7WYp+YI2fMVb07e+tJw=="/>
+      <go:slidesCustomData xmlns:go="http://customooxmlschemas.google.com/" r:id="rId20" roundtripDataSignature="AMtx7mgXtQGpK1aIBFo7P8tr4lAxlzX8+g=="/>
     </p:ext>
   </p:extLst>
 </p:presentation>
@@ -2300,7 +2300,7 @@
       </p:grpSpPr>
       <p:sp>
         <p:nvSpPr>
-          <p:cNvPr id="441" name="Google Shape;441;g3dab19ec515_10_254:notes"/>
+          <p:cNvPr id="441" name="Google Shape;441;g3dad1aee3c2_3_0:notes"/>
           <p:cNvSpPr/>
           <p:nvPr>
             <p:ph idx="2" type="sldImg"/>
@@ -2345,7 +2345,7 @@
       </p:sp>
       <p:sp>
         <p:nvSpPr>
-          <p:cNvPr id="442" name="Google Shape;442;g3dab19ec515_10_254:notes"/>
+          <p:cNvPr id="442" name="Google Shape;442;g3dad1aee3c2_3_0:notes"/>
           <p:cNvSpPr txBox="1"/>
           <p:nvPr>
             <p:ph idx="1" type="body"/>
@@ -2354,7 +2354,7 @@
         <p:spPr>
           <a:xfrm>
             <a:off x="685800" y="4400550"/>
-            <a:ext cx="5486400" cy="3600600"/>
+            <a:ext cx="5486400" cy="3600450"/>
           </a:xfrm>
           <a:prstGeom prst="rect">
             <a:avLst/>
@@ -2397,15 +2397,267 @@
                 <a:cs typeface="Calibri"/>
                 <a:sym typeface="Calibri"/>
               </a:rPr>
-              <a:t>To conclude. We started with one question: when these transformers predict emotion, are they hearing voice or reading words? Three big answers came out of twelve experiments. First, where: emotion is encoded consistently in middle-to-late layers across every encoder, every dataset and every language we tested. Second, how: the signal is acoustic, not lexical - four independent falsification tests confirm it, and Whisper is the only model that natively resists the lexical shortcut, likely because of its supervised multilingual pretraining. Third, what next: frozen probes already win on twenty-nine of thirty combos against LoRA fine-tuning, so the practical recipe is to probe, not tune. Future work would extend the SpeechCraft pooled benchmark to eight-class emotion and validate on real-world deployment audio. The bottom line: speech transformers CAN hear emotion in voice alone, but they do not always CHOOSE to. With the right probing recipe, you can locate exactly where the acoustic signal lives - and prove it is acoustic. Thank you.  </a:t>
+              <a:t>Last result before we conclude. This is Task 9 — the SpeechCraft compiled benchmark we promised in the midterm plan. We pooled four cross-lingual corpora (English, German, Greek, Spanish), about twenty thousand clips, into a balanced four-class manifest. Two evaluations on the same data: pooled stratified five-fold cross-validation, and Leave-One-Language-Out, where one entire language is held out from training and the probe is asked to transfer.</a:t>
             </a:r>
             <a:endParaRPr/>
           </a:p>
-        </p:txBody>
-      </p:sp>
-      <p:sp>
-        <p:nvSpPr>
-          <p:cNvPr id="443" name="Google Shape;443;g3dab19ec515_10_254:notes"/>
+          <a:p>
+            <a:pPr indent="-228600" lvl="0" marL="457200" marR="0" rtl="0" algn="l">
+              <a:lnSpc>
+                <a:spcPct val="100000"/>
+              </a:lnSpc>
+              <a:spcBef>
+                <a:spcPts val="0"/>
+              </a:spcBef>
+              <a:spcAft>
+                <a:spcPts val="0"/>
+              </a:spcAft>
+              <a:buClr>
+                <a:srgbClr val="000000"/>
+              </a:buClr>
+              <a:buSzPts val="1400"/>
+              <a:buFont typeface="Arial"/>
+              <a:buNone/>
+            </a:pPr>
+            <a:r>
+              <a:t/>
+            </a:r>
+            <a:endParaRPr b="0" i="0" sz="1200" u="none" cap="none" strike="noStrike">
+              <a:solidFill>
+                <a:schemeClr val="dk1"/>
+              </a:solidFill>
+              <a:latin typeface="Calibri"/>
+              <a:ea typeface="Calibri"/>
+              <a:cs typeface="Calibri"/>
+              <a:sym typeface="Calibri"/>
+            </a:endParaRPr>
+          </a:p>
+          <a:p>
+            <a:pPr indent="-228600" lvl="0" marL="457200" marR="0" rtl="0" algn="l">
+              <a:lnSpc>
+                <a:spcPct val="100000"/>
+              </a:lnSpc>
+              <a:spcBef>
+                <a:spcPts val="0"/>
+              </a:spcBef>
+              <a:spcAft>
+                <a:spcPts val="0"/>
+              </a:spcAft>
+              <a:buClr>
+                <a:srgbClr val="000000"/>
+              </a:buClr>
+              <a:buSzPts val="1400"/>
+              <a:buFont typeface="Arial"/>
+              <a:buNone/>
+            </a:pPr>
+            <a:r>
+              <a:rPr b="0" i="0" lang="en-US" sz="1200" u="none" cap="none" strike="noStrike">
+                <a:solidFill>
+                  <a:schemeClr val="dk1"/>
+                </a:solidFill>
+                <a:latin typeface="Calibri"/>
+                <a:ea typeface="Calibri"/>
+                <a:cs typeface="Calibri"/>
+                <a:sym typeface="Calibri"/>
+              </a:rPr>
+              <a:t>Three numbers tell the story. First, pooled best-layer accuracy averaged across all six encoders is 0.934 — essentially saturated. Whisper hits 0.949 at layer 10, HuBERT 0.947 at layer 8, WavLM 0.945 at layer 6, and even the weakest, MERT, still hits 0.907. So when the probe sees every language during training, the signal is overwhelming.</a:t>
+            </a:r>
+            <a:endParaRPr/>
+          </a:p>
+          <a:p>
+            <a:pPr indent="-228600" lvl="0" marL="457200" marR="0" rtl="0" algn="l">
+              <a:lnSpc>
+                <a:spcPct val="100000"/>
+              </a:lnSpc>
+              <a:spcBef>
+                <a:spcPts val="0"/>
+              </a:spcBef>
+              <a:spcAft>
+                <a:spcPts val="0"/>
+              </a:spcAft>
+              <a:buClr>
+                <a:srgbClr val="000000"/>
+              </a:buClr>
+              <a:buSzPts val="1400"/>
+              <a:buFont typeface="Arial"/>
+              <a:buNone/>
+            </a:pPr>
+            <a:r>
+              <a:t/>
+            </a:r>
+            <a:endParaRPr b="0" i="0" sz="1200" u="none" cap="none" strike="noStrike">
+              <a:solidFill>
+                <a:schemeClr val="dk1"/>
+              </a:solidFill>
+              <a:latin typeface="Calibri"/>
+              <a:ea typeface="Calibri"/>
+              <a:cs typeface="Calibri"/>
+              <a:sym typeface="Calibri"/>
+            </a:endParaRPr>
+          </a:p>
+          <a:p>
+            <a:pPr indent="-228600" lvl="0" marL="457200" marR="0" rtl="0" algn="l">
+              <a:lnSpc>
+                <a:spcPct val="100000"/>
+              </a:lnSpc>
+              <a:spcBef>
+                <a:spcPts val="0"/>
+              </a:spcBef>
+              <a:spcAft>
+                <a:spcPts val="0"/>
+              </a:spcAft>
+              <a:buClr>
+                <a:srgbClr val="000000"/>
+              </a:buClr>
+              <a:buSzPts val="1400"/>
+              <a:buFont typeface="Arial"/>
+              <a:buNone/>
+            </a:pPr>
+            <a:r>
+              <a:rPr b="0" i="0" lang="en-US" sz="1200" u="none" cap="none" strike="noStrike">
+                <a:solidFill>
+                  <a:schemeClr val="dk1"/>
+                </a:solidFill>
+                <a:latin typeface="Calibri"/>
+                <a:ea typeface="Calibri"/>
+                <a:cs typeface="Calibri"/>
+                <a:sym typeface="Calibri"/>
+              </a:rPr>
+              <a:t>Second, leave-one-language-out drops the mean to 0.695 — a 0.24 generalisation gap. That gap is the price of removing a language. But crucially, the gap is not uniform.</a:t>
+            </a:r>
+            <a:endParaRPr/>
+          </a:p>
+          <a:p>
+            <a:pPr indent="-228600" lvl="0" marL="457200" marR="0" rtl="0" algn="l">
+              <a:lnSpc>
+                <a:spcPct val="100000"/>
+              </a:lnSpc>
+              <a:spcBef>
+                <a:spcPts val="0"/>
+              </a:spcBef>
+              <a:spcAft>
+                <a:spcPts val="0"/>
+              </a:spcAft>
+              <a:buClr>
+                <a:srgbClr val="000000"/>
+              </a:buClr>
+              <a:buSzPts val="1400"/>
+              <a:buFont typeface="Arial"/>
+              <a:buNone/>
+            </a:pPr>
+            <a:r>
+              <a:t/>
+            </a:r>
+            <a:endParaRPr b="0" i="0" sz="1200" u="none" cap="none" strike="noStrike">
+              <a:solidFill>
+                <a:schemeClr val="dk1"/>
+              </a:solidFill>
+              <a:latin typeface="Calibri"/>
+              <a:ea typeface="Calibri"/>
+              <a:cs typeface="Calibri"/>
+              <a:sym typeface="Calibri"/>
+            </a:endParaRPr>
+          </a:p>
+          <a:p>
+            <a:pPr indent="-228600" lvl="0" marL="457200" marR="0" rtl="0" algn="l">
+              <a:lnSpc>
+                <a:spcPct val="100000"/>
+              </a:lnSpc>
+              <a:spcBef>
+                <a:spcPts val="0"/>
+              </a:spcBef>
+              <a:spcAft>
+                <a:spcPts val="0"/>
+              </a:spcAft>
+              <a:buClr>
+                <a:srgbClr val="000000"/>
+              </a:buClr>
+              <a:buSzPts val="1400"/>
+              <a:buFont typeface="Arial"/>
+              <a:buNone/>
+            </a:pPr>
+            <a:r>
+              <a:rPr b="0" i="0" lang="en-US" sz="1200" u="none" cap="none" strike="noStrike">
+                <a:solidFill>
+                  <a:schemeClr val="dk1"/>
+                </a:solidFill>
+                <a:latin typeface="Calibri"/>
+                <a:ea typeface="Calibri"/>
+                <a:cs typeface="Calibri"/>
+                <a:sym typeface="Calibri"/>
+              </a:rPr>
+              <a:t>Third, look at the per-language breakdown on the right. German held-out stays between 0.88 and 0.95 across all six models — transfer is almost free. Greek and English sit in the middle, around 0.6 to 0.76. Spanish collapses: HuBERT drops to 0.38, MERT to 0.41 — well below the other languages and barely above chance for some encoders. So Spanish prosody carries a different acoustic fingerprint that none of the encoders learned to share.</a:t>
+            </a:r>
+            <a:endParaRPr/>
+          </a:p>
+          <a:p>
+            <a:pPr indent="-228600" lvl="0" marL="457200" marR="0" rtl="0" algn="l">
+              <a:lnSpc>
+                <a:spcPct val="100000"/>
+              </a:lnSpc>
+              <a:spcBef>
+                <a:spcPts val="0"/>
+              </a:spcBef>
+              <a:spcAft>
+                <a:spcPts val="0"/>
+              </a:spcAft>
+              <a:buClr>
+                <a:srgbClr val="000000"/>
+              </a:buClr>
+              <a:buSzPts val="1400"/>
+              <a:buFont typeface="Arial"/>
+              <a:buNone/>
+            </a:pPr>
+            <a:r>
+              <a:t/>
+            </a:r>
+            <a:endParaRPr b="0" i="0" sz="1200" u="none" cap="none" strike="noStrike">
+              <a:solidFill>
+                <a:schemeClr val="dk1"/>
+              </a:solidFill>
+              <a:latin typeface="Calibri"/>
+              <a:ea typeface="Calibri"/>
+              <a:cs typeface="Calibri"/>
+              <a:sym typeface="Calibri"/>
+            </a:endParaRPr>
+          </a:p>
+          <a:p>
+            <a:pPr indent="-228600" lvl="0" marL="457200" marR="0" rtl="0" algn="l">
+              <a:lnSpc>
+                <a:spcPct val="100000"/>
+              </a:lnSpc>
+              <a:spcBef>
+                <a:spcPts val="0"/>
+              </a:spcBef>
+              <a:spcAft>
+                <a:spcPts val="0"/>
+              </a:spcAft>
+              <a:buClr>
+                <a:srgbClr val="000000"/>
+              </a:buClr>
+              <a:buSzPts val="1400"/>
+              <a:buFont typeface="Arial"/>
+              <a:buNone/>
+            </a:pPr>
+            <a:r>
+              <a:rPr b="0" i="0" lang="en-US" sz="1200" u="none" cap="none" strike="noStrike">
+                <a:solidFill>
+                  <a:schemeClr val="dk1"/>
+                </a:solidFill>
+                <a:latin typeface="Calibri"/>
+                <a:ea typeface="Calibri"/>
+                <a:cs typeface="Calibri"/>
+                <a:sym typeface="Calibri"/>
+              </a:rPr>
+              <a:t>Why this is the right last slide. The earlier results said the signal is acoustic. This one says the acoustic signal is real but not yet universal: it transfers to typologically and phonetically nearby languages, and breaks where the prosodic distance is largest. That is a concrete, testable boundary on the linguistic-agnostic claim — and a clean motivation for future work: extend SpeechCraft to a true cross-lingual training regime and balance the Spanish coverage.</a:t>
+            </a:r>
+            <a:endParaRPr/>
+          </a:p>
+        </p:txBody>
+      </p:sp>
+      <p:sp>
+        <p:nvSpPr>
+          <p:cNvPr id="443" name="Google Shape;443;g3dad1aee3c2_3_0:notes"/>
           <p:cNvSpPr txBox="1"/>
           <p:nvPr>
             <p:ph idx="12" type="sldNum"/>
@@ -2414,7 +2666,7 @@
         <p:spPr>
           <a:xfrm>
             <a:off x="3884613" y="8685213"/>
-            <a:ext cx="2971800" cy="458700"/>
+            <a:ext cx="2971800" cy="458787"/>
           </a:xfrm>
           <a:prstGeom prst="rect">
             <a:avLst/>
@@ -2459,7 +2711,7 @@
   <p:cSld>
     <p:spTree>
       <p:nvGrpSpPr>
-        <p:cNvPr id="469" name="Shape 469"/>
+        <p:cNvPr id="477" name="Shape 477"/>
         <p:cNvGrpSpPr/>
         <p:nvPr/>
       </p:nvGrpSpPr>
@@ -2473,7 +2725,7 @@
       </p:grpSpPr>
       <p:sp>
         <p:nvSpPr>
-          <p:cNvPr id="470" name="Google Shape;470;g3dab19ec515_5_64:notes"/>
+          <p:cNvPr id="478" name="Google Shape;478;g3dab19ec515_5_64:notes"/>
           <p:cNvSpPr/>
           <p:nvPr>
             <p:ph idx="2" type="sldImg"/>
@@ -2518,7 +2770,7 @@
       </p:sp>
       <p:sp>
         <p:nvSpPr>
-          <p:cNvPr id="471" name="Google Shape;471;g3dab19ec515_5_64:notes"/>
+          <p:cNvPr id="479" name="Google Shape;479;g3dab19ec515_5_64:notes"/>
           <p:cNvSpPr txBox="1"/>
           <p:nvPr>
             <p:ph idx="1" type="body"/>
@@ -2578,7 +2830,7 @@
       </p:sp>
       <p:sp>
         <p:nvSpPr>
-          <p:cNvPr id="472" name="Google Shape;472;g3dab19ec515_5_64:notes"/>
+          <p:cNvPr id="480" name="Google Shape;480;g3dab19ec515_5_64:notes"/>
           <p:cNvSpPr txBox="1"/>
           <p:nvPr>
             <p:ph idx="12" type="sldNum"/>
@@ -2636,7 +2888,7 @@
   <p:cSld>
     <p:spTree>
       <p:nvGrpSpPr>
-        <p:cNvPr id="498" name="Shape 498"/>
+        <p:cNvPr id="506" name="Shape 506"/>
         <p:cNvGrpSpPr/>
         <p:nvPr/>
       </p:nvGrpSpPr>
@@ -2650,7 +2902,7 @@
       </p:grpSpPr>
       <p:sp>
         <p:nvSpPr>
-          <p:cNvPr id="499" name="Google Shape;499;g3dab19ec515_12_0:notes"/>
+          <p:cNvPr id="507" name="Google Shape;507;g3dab19ec515_12_0:notes"/>
           <p:cNvSpPr/>
           <p:nvPr>
             <p:ph idx="2" type="sldImg"/>
@@ -2695,7 +2947,7 @@
       </p:sp>
       <p:sp>
         <p:nvSpPr>
-          <p:cNvPr id="500" name="Google Shape;500;g3dab19ec515_12_0:notes"/>
+          <p:cNvPr id="508" name="Google Shape;508;g3dab19ec515_12_0:notes"/>
           <p:cNvSpPr txBox="1"/>
           <p:nvPr>
             <p:ph idx="1" type="body"/>
@@ -2746,7 +2998,7 @@
       </p:sp>
       <p:sp>
         <p:nvSpPr>
-          <p:cNvPr id="501" name="Google Shape;501;g3dab19ec515_12_0:notes"/>
+          <p:cNvPr id="509" name="Google Shape;509;g3dab19ec515_12_0:notes"/>
           <p:cNvSpPr txBox="1"/>
           <p:nvPr>
             <p:ph idx="12" type="sldNum"/>
@@ -2804,7 +3056,7 @@
   <p:cSld>
     <p:spTree>
       <p:nvGrpSpPr>
-        <p:cNvPr id="546" name="Shape 546"/>
+        <p:cNvPr id="554" name="Shape 554"/>
         <p:cNvGrpSpPr/>
         <p:nvPr/>
       </p:nvGrpSpPr>
@@ -2818,7 +3070,7 @@
       </p:grpSpPr>
       <p:sp>
         <p:nvSpPr>
-          <p:cNvPr id="547" name="Google Shape;547;g3dab19ec515_10_282:notes"/>
+          <p:cNvPr id="555" name="Google Shape;555;g3dab19ec515_10_282:notes"/>
           <p:cNvSpPr/>
           <p:nvPr>
             <p:ph idx="2" type="sldImg"/>
@@ -2863,7 +3115,7 @@
       </p:sp>
       <p:sp>
         <p:nvSpPr>
-          <p:cNvPr id="548" name="Google Shape;548;g3dab19ec515_10_282:notes"/>
+          <p:cNvPr id="556" name="Google Shape;556;g3dab19ec515_10_282:notes"/>
           <p:cNvSpPr txBox="1"/>
           <p:nvPr>
             <p:ph idx="1" type="body"/>
@@ -2923,7 +3175,7 @@
       </p:sp>
       <p:sp>
         <p:nvSpPr>
-          <p:cNvPr id="549" name="Google Shape;549;g3dab19ec515_10_282:notes"/>
+          <p:cNvPr id="557" name="Google Shape;557;g3dab19ec515_10_282:notes"/>
           <p:cNvSpPr txBox="1"/>
           <p:nvPr>
             <p:ph idx="12" type="sldNum"/>
@@ -8312,20 +8564,20 @@
       </p:grpSpPr>
       <p:sp>
         <p:nvSpPr>
-          <p:cNvPr id="445" name="Google Shape;445;g3dab19ec515_10_254"/>
+          <p:cNvPr id="445" name="Google Shape;445;g3dad1aee3c2_3_0"/>
           <p:cNvSpPr/>
           <p:nvPr/>
         </p:nvSpPr>
         <p:spPr>
           <a:xfrm>
             <a:off x="0" y="0"/>
-            <a:ext cx="12191700" cy="6858000"/>
+            <a:ext cx="1463040" cy="411480"/>
           </a:xfrm>
           <a:prstGeom prst="rect">
             <a:avLst/>
           </a:prstGeom>
           <a:solidFill>
-            <a:srgbClr val="FFFFFF"/>
+            <a:srgbClr val="1E2761"/>
           </a:solidFill>
           <a:ln>
             <a:noFill/>
@@ -8366,20 +8618,179 @@
       </p:sp>
       <p:sp>
         <p:nvSpPr>
-          <p:cNvPr id="446" name="Google Shape;446;g3dab19ec515_10_254"/>
+          <p:cNvPr id="446" name="Google Shape;446;g3dad1aee3c2_3_0"/>
+          <p:cNvSpPr txBox="1"/>
+          <p:nvPr/>
+        </p:nvSpPr>
+        <p:spPr>
+          <a:xfrm>
+            <a:off x="137160" y="45720"/>
+            <a:ext cx="1325880" cy="320040"/>
+          </a:xfrm>
+          <a:prstGeom prst="rect">
+            <a:avLst/>
+          </a:prstGeom>
+          <a:noFill/>
+          <a:ln>
+            <a:noFill/>
+          </a:ln>
+        </p:spPr>
+        <p:txBody>
+          <a:bodyPr anchorCtr="0" anchor="ctr" bIns="0" lIns="0" spcFirstLastPara="1" rIns="0" wrap="square" tIns="0">
+            <a:spAutoFit/>
+          </a:bodyPr>
+          <a:lstStyle/>
+          <a:p>
+            <a:pPr indent="0" lvl="0" marL="0" marR="0" rtl="0" algn="l">
+              <a:lnSpc>
+                <a:spcPct val="100000"/>
+              </a:lnSpc>
+              <a:spcBef>
+                <a:spcPts val="0"/>
+              </a:spcBef>
+              <a:spcAft>
+                <a:spcPts val="0"/>
+              </a:spcAft>
+              <a:buNone/>
+            </a:pPr>
+            <a:r>
+              <a:rPr b="1" i="0" lang="en-US" sz="1500" u="none" cap="none" strike="noStrike">
+                <a:solidFill>
+                  <a:srgbClr val="FFFFFF"/>
+                </a:solidFill>
+                <a:latin typeface="Calibri"/>
+                <a:ea typeface="Calibri"/>
+                <a:cs typeface="Calibri"/>
+                <a:sym typeface="Calibri"/>
+              </a:rPr>
+              <a:t> RESULTS</a:t>
+            </a:r>
+            <a:endParaRPr/>
+          </a:p>
+        </p:txBody>
+      </p:sp>
+      <p:sp>
+        <p:nvSpPr>
+          <p:cNvPr id="447" name="Google Shape;447;g3dad1aee3c2_3_0"/>
+          <p:cNvSpPr txBox="1"/>
+          <p:nvPr/>
+        </p:nvSpPr>
+        <p:spPr>
+          <a:xfrm>
+            <a:off x="457200" y="566928"/>
+            <a:ext cx="11247000" cy="585000"/>
+          </a:xfrm>
+          <a:prstGeom prst="rect">
+            <a:avLst/>
+          </a:prstGeom>
+          <a:noFill/>
+          <a:ln>
+            <a:noFill/>
+          </a:ln>
+        </p:spPr>
+        <p:txBody>
+          <a:bodyPr anchorCtr="0" anchor="t" bIns="0" lIns="0" spcFirstLastPara="1" rIns="0" wrap="square" tIns="0">
+            <a:spAutoFit/>
+          </a:bodyPr>
+          <a:lstStyle/>
+          <a:p>
+            <a:pPr indent="0" lvl="0" marL="0" marR="0" rtl="0" algn="l">
+              <a:lnSpc>
+                <a:spcPct val="100000"/>
+              </a:lnSpc>
+              <a:spcBef>
+                <a:spcPts val="0"/>
+              </a:spcBef>
+              <a:spcAft>
+                <a:spcPts val="0"/>
+              </a:spcAft>
+              <a:buNone/>
+            </a:pPr>
+            <a:r>
+              <a:rPr b="1" i="0" lang="en-US" sz="3800" u="none" cap="none" strike="noStrike">
+                <a:solidFill>
+                  <a:srgbClr val="1E2761"/>
+                </a:solidFill>
+                <a:latin typeface="Calibri"/>
+                <a:ea typeface="Calibri"/>
+                <a:cs typeface="Calibri"/>
+                <a:sym typeface="Calibri"/>
+              </a:rPr>
+              <a:t>Cross-lingual stress test on SpeechCraft</a:t>
+            </a:r>
+            <a:endParaRPr sz="1900"/>
+          </a:p>
+        </p:txBody>
+      </p:sp>
+      <p:sp>
+        <p:nvSpPr>
+          <p:cNvPr id="448" name="Google Shape;448;g3dad1aee3c2_3_0"/>
+          <p:cNvSpPr txBox="1"/>
+          <p:nvPr/>
+        </p:nvSpPr>
+        <p:spPr>
+          <a:xfrm>
+            <a:off x="475488" y="1170432"/>
+            <a:ext cx="11247000" cy="461700"/>
+          </a:xfrm>
+          <a:prstGeom prst="rect">
+            <a:avLst/>
+          </a:prstGeom>
+          <a:noFill/>
+          <a:ln>
+            <a:noFill/>
+          </a:ln>
+        </p:spPr>
+        <p:txBody>
+          <a:bodyPr anchorCtr="0" anchor="t" bIns="0" lIns="0" spcFirstLastPara="1" rIns="0" wrap="square" tIns="0">
+            <a:spAutoFit/>
+          </a:bodyPr>
+          <a:lstStyle/>
+          <a:p>
+            <a:pPr indent="0" lvl="0" marL="0" marR="0" rtl="0" algn="l">
+              <a:lnSpc>
+                <a:spcPct val="100000"/>
+              </a:lnSpc>
+              <a:spcBef>
+                <a:spcPts val="0"/>
+              </a:spcBef>
+              <a:spcAft>
+                <a:spcPts val="0"/>
+              </a:spcAft>
+              <a:buNone/>
+            </a:pPr>
+            <a:r>
+              <a:rPr b="1" i="0" lang="en-US" sz="1500" u="none" cap="none" strike="noStrike">
+                <a:solidFill>
+                  <a:srgbClr val="64748B"/>
+                </a:solidFill>
+                <a:latin typeface="Calibri"/>
+                <a:ea typeface="Calibri"/>
+                <a:cs typeface="Calibri"/>
+                <a:sym typeface="Calibri"/>
+              </a:rPr>
+              <a:t>Pooled CV vs leave-one-language-out across 6 encoders · 4 languages · ≈ 20k clips — does the layer pattern survive when a whole language is removed from training?</a:t>
+            </a:r>
+            <a:endParaRPr sz="1500"/>
+          </a:p>
+        </p:txBody>
+      </p:sp>
+      <p:sp>
+        <p:nvSpPr>
+          <p:cNvPr id="449" name="Google Shape;449;g3dad1aee3c2_3_0"/>
           <p:cNvSpPr/>
           <p:nvPr/>
         </p:nvSpPr>
         <p:spPr>
           <a:xfrm>
-            <a:off x="0" y="0"/>
-            <a:ext cx="1417200" cy="457200"/>
+            <a:off x="457200" y="1783080"/>
+            <a:ext cx="5239512" cy="4251960"/>
           </a:xfrm>
           <a:prstGeom prst="rect">
             <a:avLst/>
           </a:prstGeom>
           <a:solidFill>
-            <a:srgbClr val="142147"/>
+            <a:srgbClr val="F1F5F9"/>
           </a:solidFill>
           <a:ln>
             <a:noFill/>
@@ -8420,14 +8831,14 @@
       </p:sp>
       <p:sp>
         <p:nvSpPr>
-          <p:cNvPr id="447" name="Google Shape;447;g3dab19ec515_10_254"/>
+          <p:cNvPr id="450" name="Google Shape;450;g3dad1aee3c2_3_0"/>
           <p:cNvSpPr txBox="1"/>
           <p:nvPr/>
         </p:nvSpPr>
         <p:spPr>
           <a:xfrm>
-            <a:off x="164592" y="118872"/>
-            <a:ext cx="1280100" cy="274200"/>
+            <a:off x="640080" y="1874519"/>
+            <a:ext cx="4937700" cy="246300"/>
           </a:xfrm>
           <a:prstGeom prst="rect">
             <a:avLst/>
@@ -8456,31 +8867,31 @@
               <a:buNone/>
             </a:pPr>
             <a:r>
-              <a:rPr b="1" i="0" lang="en-US" sz="1400" u="none" cap="none" strike="noStrike">
-                <a:solidFill>
-                  <a:srgbClr val="FFFFFF"/>
-                </a:solidFill>
-                <a:latin typeface="Calibri"/>
-                <a:ea typeface="Calibri"/>
-                <a:cs typeface="Calibri"/>
-                <a:sym typeface="Calibri"/>
-              </a:rPr>
-              <a:t>CONCLUSION</a:t>
-            </a:r>
-            <a:endParaRPr/>
-          </a:p>
-        </p:txBody>
-      </p:sp>
-      <p:sp>
-        <p:nvSpPr>
-          <p:cNvPr id="448" name="Google Shape;448;g3dab19ec515_10_254"/>
+              <a:rPr b="1" i="0" lang="en-US" sz="1600" u="none" cap="none" strike="noStrike">
+                <a:solidFill>
+                  <a:srgbClr val="1E2761"/>
+                </a:solidFill>
+                <a:latin typeface="Calibri"/>
+                <a:ea typeface="Calibri"/>
+                <a:cs typeface="Calibri"/>
+                <a:sym typeface="Calibri"/>
+              </a:rPr>
+              <a:t>SpeechCraft pooled · 6 encoders × 4 languages</a:t>
+            </a:r>
+            <a:endParaRPr sz="1500"/>
+          </a:p>
+        </p:txBody>
+      </p:sp>
+      <p:sp>
+        <p:nvSpPr>
+          <p:cNvPr id="451" name="Google Shape;451;g3dad1aee3c2_3_0"/>
           <p:cNvSpPr txBox="1"/>
           <p:nvPr/>
         </p:nvSpPr>
         <p:spPr>
           <a:xfrm>
-            <a:off x="502920" y="640080"/>
-            <a:ext cx="11430000" cy="523200"/>
+            <a:off x="640080" y="2240280"/>
+            <a:ext cx="1691640" cy="777240"/>
           </a:xfrm>
           <a:prstGeom prst="rect">
             <a:avLst/>
@@ -8498,42 +8909,42 @@
           <a:p>
             <a:pPr indent="0" lvl="0" marL="0" marR="0" rtl="0" algn="l">
               <a:lnSpc>
-                <a:spcPct val="105000"/>
-              </a:lnSpc>
-              <a:spcBef>
-                <a:spcPts val="0"/>
-              </a:spcBef>
-              <a:spcAft>
-                <a:spcPts val="0"/>
-              </a:spcAft>
-              <a:buNone/>
-            </a:pPr>
-            <a:r>
-              <a:rPr b="1" i="0" lang="en-US" sz="3400" u="none" cap="none" strike="noStrike">
-                <a:solidFill>
-                  <a:srgbClr val="1A2A57"/>
-                </a:solidFill>
-                <a:latin typeface="Calibri"/>
-                <a:ea typeface="Calibri"/>
-                <a:cs typeface="Calibri"/>
-                <a:sym typeface="Calibri"/>
-              </a:rPr>
-              <a:t>What we now know about emotion in speech transformers</a:t>
-            </a:r>
-            <a:endParaRPr sz="1800"/>
-          </a:p>
-        </p:txBody>
-      </p:sp>
-      <p:sp>
-        <p:nvSpPr>
-          <p:cNvPr id="449" name="Google Shape;449;g3dab19ec515_10_254"/>
+                <a:spcPct val="100000"/>
+              </a:lnSpc>
+              <a:spcBef>
+                <a:spcPts val="0"/>
+              </a:spcBef>
+              <a:spcAft>
+                <a:spcPts val="0"/>
+              </a:spcAft>
+              <a:buNone/>
+            </a:pPr>
+            <a:r>
+              <a:rPr b="1" i="0" lang="en-US" sz="4800" u="none" cap="none" strike="noStrike">
+                <a:solidFill>
+                  <a:srgbClr val="1E2761"/>
+                </a:solidFill>
+                <a:latin typeface="Calibri"/>
+                <a:ea typeface="Calibri"/>
+                <a:cs typeface="Calibri"/>
+                <a:sym typeface="Calibri"/>
+              </a:rPr>
+              <a:t>0.934</a:t>
+            </a:r>
+            <a:endParaRPr/>
+          </a:p>
+        </p:txBody>
+      </p:sp>
+      <p:sp>
+        <p:nvSpPr>
+          <p:cNvPr id="452" name="Google Shape;452;g3dad1aee3c2_3_0"/>
           <p:cNvSpPr txBox="1"/>
           <p:nvPr/>
         </p:nvSpPr>
         <p:spPr>
           <a:xfrm>
-            <a:off x="502920" y="1243584"/>
-            <a:ext cx="11430000" cy="231000"/>
+            <a:off x="640080" y="3017520"/>
+            <a:ext cx="1691640" cy="566928"/>
           </a:xfrm>
           <a:prstGeom prst="rect">
             <a:avLst/>
@@ -8551,59 +8962,1234 @@
           <a:p>
             <a:pPr indent="0" lvl="0" marL="0" marR="0" rtl="0" algn="l">
               <a:lnSpc>
-                <a:spcPct val="115000"/>
-              </a:lnSpc>
-              <a:spcBef>
-                <a:spcPts val="0"/>
-              </a:spcBef>
-              <a:spcAft>
-                <a:spcPts val="0"/>
-              </a:spcAft>
-              <a:buNone/>
-            </a:pPr>
-            <a:r>
-              <a:rPr b="1" i="1" lang="en-US" sz="1500" u="none" cap="none" strike="noStrike">
-                <a:solidFill>
-                  <a:srgbClr val="6B7280"/>
-                </a:solidFill>
-                <a:latin typeface="Calibri"/>
-                <a:ea typeface="Calibri"/>
-                <a:cs typeface="Calibri"/>
-                <a:sym typeface="Calibri"/>
-              </a:rPr>
-              <a:t>And what comes next.</a:t>
-            </a:r>
-            <a:endParaRPr b="1"/>
-          </a:p>
-        </p:txBody>
-      </p:sp>
-      <p:sp>
-        <p:nvSpPr>
-          <p:cNvPr id="450" name="Google Shape;450;g3dab19ec515_10_254"/>
+                <a:spcPct val="100000"/>
+              </a:lnSpc>
+              <a:spcBef>
+                <a:spcPts val="0"/>
+              </a:spcBef>
+              <a:spcAft>
+                <a:spcPts val="0"/>
+              </a:spcAft>
+              <a:buNone/>
+            </a:pPr>
+            <a:r>
+              <a:rPr b="0" i="0" lang="en-US" sz="1200" u="none" cap="none" strike="noStrike">
+                <a:solidFill>
+                  <a:srgbClr val="64748B"/>
+                </a:solidFill>
+                <a:latin typeface="Calibri"/>
+                <a:ea typeface="Calibri"/>
+                <a:cs typeface="Calibri"/>
+                <a:sym typeface="Calibri"/>
+              </a:rPr>
+              <a:t>pooled best-layer mean</a:t>
+            </a:r>
+            <a:endParaRPr/>
+          </a:p>
+          <a:p>
+            <a:pPr indent="0" lvl="0" marL="0" marR="0" rtl="0" algn="l">
+              <a:lnSpc>
+                <a:spcPct val="100000"/>
+              </a:lnSpc>
+              <a:spcBef>
+                <a:spcPts val="0"/>
+              </a:spcBef>
+              <a:spcAft>
+                <a:spcPts val="0"/>
+              </a:spcAft>
+              <a:buNone/>
+            </a:pPr>
+            <a:r>
+              <a:rPr b="0" i="0" lang="en-US" sz="1200" u="none" cap="none" strike="noStrike">
+                <a:solidFill>
+                  <a:srgbClr val="64748B"/>
+                </a:solidFill>
+                <a:latin typeface="Calibri"/>
+                <a:ea typeface="Calibri"/>
+                <a:cs typeface="Calibri"/>
+                <a:sym typeface="Calibri"/>
+              </a:rPr>
+              <a:t>across 6 encoders</a:t>
+            </a:r>
+            <a:endParaRPr/>
+          </a:p>
+        </p:txBody>
+      </p:sp>
+      <p:sp>
+        <p:nvSpPr>
+          <p:cNvPr id="453" name="Google Shape;453;g3dad1aee3c2_3_0"/>
+          <p:cNvSpPr txBox="1"/>
+          <p:nvPr/>
+        </p:nvSpPr>
+        <p:spPr>
+          <a:xfrm>
+            <a:off x="2395728" y="2240280"/>
+            <a:ext cx="1691640" cy="777240"/>
+          </a:xfrm>
+          <a:prstGeom prst="rect">
+            <a:avLst/>
+          </a:prstGeom>
+          <a:noFill/>
+          <a:ln>
+            <a:noFill/>
+          </a:ln>
+        </p:spPr>
+        <p:txBody>
+          <a:bodyPr anchorCtr="0" anchor="t" bIns="0" lIns="0" spcFirstLastPara="1" rIns="0" wrap="square" tIns="0">
+            <a:spAutoFit/>
+          </a:bodyPr>
+          <a:lstStyle/>
+          <a:p>
+            <a:pPr indent="0" lvl="0" marL="0" marR="0" rtl="0" algn="l">
+              <a:lnSpc>
+                <a:spcPct val="100000"/>
+              </a:lnSpc>
+              <a:spcBef>
+                <a:spcPts val="0"/>
+              </a:spcBef>
+              <a:spcAft>
+                <a:spcPts val="0"/>
+              </a:spcAft>
+              <a:buNone/>
+            </a:pPr>
+            <a:r>
+              <a:rPr b="1" i="0" lang="en-US" sz="4800" u="none" cap="none" strike="noStrike">
+                <a:solidFill>
+                  <a:srgbClr val="1E2761"/>
+                </a:solidFill>
+                <a:latin typeface="Calibri"/>
+                <a:ea typeface="Calibri"/>
+                <a:cs typeface="Calibri"/>
+                <a:sym typeface="Calibri"/>
+              </a:rPr>
+              <a:t>0.695</a:t>
+            </a:r>
+            <a:endParaRPr/>
+          </a:p>
+        </p:txBody>
+      </p:sp>
+      <p:sp>
+        <p:nvSpPr>
+          <p:cNvPr id="454" name="Google Shape;454;g3dad1aee3c2_3_0"/>
+          <p:cNvSpPr txBox="1"/>
+          <p:nvPr/>
+        </p:nvSpPr>
+        <p:spPr>
+          <a:xfrm>
+            <a:off x="2395728" y="3017520"/>
+            <a:ext cx="1691640" cy="566928"/>
+          </a:xfrm>
+          <a:prstGeom prst="rect">
+            <a:avLst/>
+          </a:prstGeom>
+          <a:noFill/>
+          <a:ln>
+            <a:noFill/>
+          </a:ln>
+        </p:spPr>
+        <p:txBody>
+          <a:bodyPr anchorCtr="0" anchor="t" bIns="0" lIns="0" spcFirstLastPara="1" rIns="0" wrap="square" tIns="0">
+            <a:spAutoFit/>
+          </a:bodyPr>
+          <a:lstStyle/>
+          <a:p>
+            <a:pPr indent="0" lvl="0" marL="0" marR="0" rtl="0" algn="l">
+              <a:lnSpc>
+                <a:spcPct val="100000"/>
+              </a:lnSpc>
+              <a:spcBef>
+                <a:spcPts val="0"/>
+              </a:spcBef>
+              <a:spcAft>
+                <a:spcPts val="0"/>
+              </a:spcAft>
+              <a:buNone/>
+            </a:pPr>
+            <a:r>
+              <a:rPr b="0" i="0" lang="en-US" sz="1200" u="none" cap="none" strike="noStrike">
+                <a:solidFill>
+                  <a:srgbClr val="64748B"/>
+                </a:solidFill>
+                <a:latin typeface="Calibri"/>
+                <a:ea typeface="Calibri"/>
+                <a:cs typeface="Calibri"/>
+                <a:sym typeface="Calibri"/>
+              </a:rPr>
+              <a:t>LOLO mean best-layer</a:t>
+            </a:r>
+            <a:endParaRPr/>
+          </a:p>
+          <a:p>
+            <a:pPr indent="0" lvl="0" marL="0" marR="0" rtl="0" algn="l">
+              <a:lnSpc>
+                <a:spcPct val="100000"/>
+              </a:lnSpc>
+              <a:spcBef>
+                <a:spcPts val="0"/>
+              </a:spcBef>
+              <a:spcAft>
+                <a:spcPts val="0"/>
+              </a:spcAft>
+              <a:buNone/>
+            </a:pPr>
+            <a:r>
+              <a:rPr b="0" i="0" lang="en-US" sz="1200" u="none" cap="none" strike="noStrike">
+                <a:solidFill>
+                  <a:srgbClr val="64748B"/>
+                </a:solidFill>
+                <a:latin typeface="Calibri"/>
+                <a:ea typeface="Calibri"/>
+                <a:cs typeface="Calibri"/>
+                <a:sym typeface="Calibri"/>
+              </a:rPr>
+              <a:t>over 4 held-out languages</a:t>
+            </a:r>
+            <a:endParaRPr/>
+          </a:p>
+        </p:txBody>
+      </p:sp>
+      <p:sp>
+        <p:nvSpPr>
+          <p:cNvPr id="455" name="Google Shape;455;g3dad1aee3c2_3_0"/>
+          <p:cNvSpPr txBox="1"/>
+          <p:nvPr/>
+        </p:nvSpPr>
+        <p:spPr>
+          <a:xfrm>
+            <a:off x="4160520" y="2240280"/>
+            <a:ext cx="1508760" cy="777240"/>
+          </a:xfrm>
+          <a:prstGeom prst="rect">
+            <a:avLst/>
+          </a:prstGeom>
+          <a:noFill/>
+          <a:ln>
+            <a:noFill/>
+          </a:ln>
+        </p:spPr>
+        <p:txBody>
+          <a:bodyPr anchorCtr="0" anchor="t" bIns="0" lIns="0" spcFirstLastPara="1" rIns="0" wrap="square" tIns="0">
+            <a:spAutoFit/>
+          </a:bodyPr>
+          <a:lstStyle/>
+          <a:p>
+            <a:pPr indent="0" lvl="0" marL="0" marR="0" rtl="0" algn="l">
+              <a:lnSpc>
+                <a:spcPct val="100000"/>
+              </a:lnSpc>
+              <a:spcBef>
+                <a:spcPts val="0"/>
+              </a:spcBef>
+              <a:spcAft>
+                <a:spcPts val="0"/>
+              </a:spcAft>
+              <a:buNone/>
+            </a:pPr>
+            <a:r>
+              <a:rPr b="1" i="0" lang="en-US" sz="4800" u="none" cap="none" strike="noStrike">
+                <a:solidFill>
+                  <a:srgbClr val="F4A261"/>
+                </a:solidFill>
+                <a:latin typeface="Calibri"/>
+                <a:ea typeface="Calibri"/>
+                <a:cs typeface="Calibri"/>
+                <a:sym typeface="Calibri"/>
+              </a:rPr>
+              <a:t>+0.24</a:t>
+            </a:r>
+            <a:endParaRPr/>
+          </a:p>
+        </p:txBody>
+      </p:sp>
+      <p:sp>
+        <p:nvSpPr>
+          <p:cNvPr id="456" name="Google Shape;456;g3dad1aee3c2_3_0"/>
+          <p:cNvSpPr txBox="1"/>
+          <p:nvPr/>
+        </p:nvSpPr>
+        <p:spPr>
+          <a:xfrm>
+            <a:off x="4160520" y="3017520"/>
+            <a:ext cx="1508760" cy="566928"/>
+          </a:xfrm>
+          <a:prstGeom prst="rect">
+            <a:avLst/>
+          </a:prstGeom>
+          <a:noFill/>
+          <a:ln>
+            <a:noFill/>
+          </a:ln>
+        </p:spPr>
+        <p:txBody>
+          <a:bodyPr anchorCtr="0" anchor="t" bIns="0" lIns="0" spcFirstLastPara="1" rIns="0" wrap="square" tIns="0">
+            <a:spAutoFit/>
+          </a:bodyPr>
+          <a:lstStyle/>
+          <a:p>
+            <a:pPr indent="0" lvl="0" marL="0" marR="0" rtl="0" algn="l">
+              <a:lnSpc>
+                <a:spcPct val="100000"/>
+              </a:lnSpc>
+              <a:spcBef>
+                <a:spcPts val="0"/>
+              </a:spcBef>
+              <a:spcAft>
+                <a:spcPts val="0"/>
+              </a:spcAft>
+              <a:buNone/>
+            </a:pPr>
+            <a:r>
+              <a:rPr b="0" i="0" lang="en-US" sz="1200" u="none" cap="none" strike="noStrike">
+                <a:solidFill>
+                  <a:srgbClr val="64748B"/>
+                </a:solidFill>
+                <a:latin typeface="Calibri"/>
+                <a:ea typeface="Calibri"/>
+                <a:cs typeface="Calibri"/>
+                <a:sym typeface="Calibri"/>
+              </a:rPr>
+              <a:t>generalisation gap</a:t>
+            </a:r>
+            <a:endParaRPr/>
+          </a:p>
+          <a:p>
+            <a:pPr indent="0" lvl="0" marL="0" marR="0" rtl="0" algn="l">
+              <a:lnSpc>
+                <a:spcPct val="100000"/>
+              </a:lnSpc>
+              <a:spcBef>
+                <a:spcPts val="0"/>
+              </a:spcBef>
+              <a:spcAft>
+                <a:spcPts val="0"/>
+              </a:spcAft>
+              <a:buNone/>
+            </a:pPr>
+            <a:r>
+              <a:rPr b="0" i="0" lang="en-US" sz="1200" u="none" cap="none" strike="noStrike">
+                <a:solidFill>
+                  <a:srgbClr val="64748B"/>
+                </a:solidFill>
+                <a:latin typeface="Calibri"/>
+                <a:ea typeface="Calibri"/>
+                <a:cs typeface="Calibri"/>
+                <a:sym typeface="Calibri"/>
+              </a:rPr>
+              <a:t>(pooled − LOLO mean)</a:t>
+            </a:r>
+            <a:endParaRPr/>
+          </a:p>
+        </p:txBody>
+      </p:sp>
+      <p:sp>
+        <p:nvSpPr>
+          <p:cNvPr id="457" name="Google Shape;457;g3dad1aee3c2_3_0"/>
+          <p:cNvSpPr txBox="1"/>
+          <p:nvPr/>
+        </p:nvSpPr>
+        <p:spPr>
+          <a:xfrm>
+            <a:off x="640080" y="3664202"/>
+            <a:ext cx="4937700" cy="231000"/>
+          </a:xfrm>
+          <a:prstGeom prst="rect">
+            <a:avLst/>
+          </a:prstGeom>
+          <a:noFill/>
+          <a:ln>
+            <a:noFill/>
+          </a:ln>
+        </p:spPr>
+        <p:txBody>
+          <a:bodyPr anchorCtr="0" anchor="t" bIns="0" lIns="0" spcFirstLastPara="1" rIns="0" wrap="square" tIns="0">
+            <a:spAutoFit/>
+          </a:bodyPr>
+          <a:lstStyle/>
+          <a:p>
+            <a:pPr indent="0" lvl="0" marL="0" marR="0" rtl="0" algn="l">
+              <a:lnSpc>
+                <a:spcPct val="100000"/>
+              </a:lnSpc>
+              <a:spcBef>
+                <a:spcPts val="0"/>
+              </a:spcBef>
+              <a:spcAft>
+                <a:spcPts val="0"/>
+              </a:spcAft>
+              <a:buNone/>
+            </a:pPr>
+            <a:r>
+              <a:rPr b="1" i="0" lang="en-US" sz="1500" u="none" cap="none" strike="noStrike">
+                <a:solidFill>
+                  <a:srgbClr val="0F172A"/>
+                </a:solidFill>
+                <a:latin typeface="Calibri"/>
+                <a:ea typeface="Calibri"/>
+                <a:cs typeface="Calibri"/>
+                <a:sym typeface="Calibri"/>
+              </a:rPr>
+              <a:t>Best pooled layer per encoder</a:t>
+            </a:r>
+            <a:endParaRPr sz="1600"/>
+          </a:p>
+        </p:txBody>
+      </p:sp>
+      <p:sp>
+        <p:nvSpPr>
+          <p:cNvPr id="458" name="Google Shape;458;g3dad1aee3c2_3_0"/>
+          <p:cNvSpPr txBox="1"/>
+          <p:nvPr/>
+        </p:nvSpPr>
+        <p:spPr>
+          <a:xfrm>
+            <a:off x="640080" y="3984243"/>
+            <a:ext cx="4937700" cy="200100"/>
+          </a:xfrm>
+          <a:prstGeom prst="rect">
+            <a:avLst/>
+          </a:prstGeom>
+          <a:noFill/>
+          <a:ln>
+            <a:noFill/>
+          </a:ln>
+        </p:spPr>
+        <p:txBody>
+          <a:bodyPr anchorCtr="0" anchor="ctr" bIns="0" lIns="0" spcFirstLastPara="1" rIns="0" wrap="square" tIns="0">
+            <a:noAutofit/>
+          </a:bodyPr>
+          <a:lstStyle/>
+          <a:p>
+            <a:pPr indent="0" lvl="0" marL="0" marR="0" rtl="0" algn="l">
+              <a:lnSpc>
+                <a:spcPct val="100000"/>
+              </a:lnSpc>
+              <a:spcBef>
+                <a:spcPts val="0"/>
+              </a:spcBef>
+              <a:spcAft>
+                <a:spcPts val="0"/>
+              </a:spcAft>
+              <a:buNone/>
+            </a:pPr>
+            <a:r>
+              <a:rPr b="1" i="0" lang="en-US" u="none" cap="none" strike="noStrike">
+                <a:solidFill>
+                  <a:srgbClr val="0F172A"/>
+                </a:solidFill>
+                <a:latin typeface="Calibri"/>
+                <a:ea typeface="Calibri"/>
+                <a:cs typeface="Calibri"/>
+                <a:sym typeface="Calibri"/>
+              </a:rPr>
+              <a:t>Whisper</a:t>
+            </a:r>
+            <a:r>
+              <a:rPr lang="en-US">
+                <a:solidFill>
+                  <a:srgbClr val="64748B"/>
+                </a:solidFill>
+                <a:latin typeface="Calibri"/>
+                <a:ea typeface="Calibri"/>
+                <a:cs typeface="Calibri"/>
+                <a:sym typeface="Calibri"/>
+              </a:rPr>
+              <a:t>	-	</a:t>
+            </a:r>
+            <a:r>
+              <a:rPr b="1" i="0" lang="en-US" u="none" cap="none" strike="noStrike">
+                <a:solidFill>
+                  <a:srgbClr val="1E2761"/>
+                </a:solidFill>
+                <a:latin typeface="Calibri"/>
+                <a:ea typeface="Calibri"/>
+                <a:cs typeface="Calibri"/>
+                <a:sym typeface="Calibri"/>
+              </a:rPr>
+              <a:t>L10</a:t>
+            </a:r>
+            <a:r>
+              <a:rPr lang="en-US">
+                <a:solidFill>
+                  <a:srgbClr val="64748B"/>
+                </a:solidFill>
+                <a:latin typeface="Calibri"/>
+                <a:ea typeface="Calibri"/>
+                <a:cs typeface="Calibri"/>
+                <a:sym typeface="Calibri"/>
+              </a:rPr>
+              <a:t>	-	</a:t>
+            </a:r>
+            <a:r>
+              <a:rPr b="0" i="0" lang="en-US" u="none" cap="none" strike="noStrike">
+                <a:solidFill>
+                  <a:srgbClr val="64748B"/>
+                </a:solidFill>
+                <a:latin typeface="Calibri"/>
+                <a:ea typeface="Calibri"/>
+                <a:cs typeface="Calibri"/>
+                <a:sym typeface="Calibri"/>
+              </a:rPr>
+              <a:t>acc</a:t>
+            </a:r>
+            <a:r>
+              <a:rPr b="0" i="0" lang="en-US" u="none" cap="none" strike="noStrike">
+                <a:solidFill>
+                  <a:srgbClr val="64748B"/>
+                </a:solidFill>
+                <a:latin typeface="Calibri"/>
+                <a:ea typeface="Calibri"/>
+                <a:cs typeface="Calibri"/>
+                <a:sym typeface="Calibri"/>
+              </a:rPr>
+              <a:t> = </a:t>
+            </a:r>
+            <a:r>
+              <a:rPr b="1" i="0" lang="en-US" u="none" cap="none" strike="noStrike">
+                <a:solidFill>
+                  <a:srgbClr val="0F172A"/>
+                </a:solidFill>
+                <a:latin typeface="Calibri"/>
+                <a:ea typeface="Calibri"/>
+                <a:cs typeface="Calibri"/>
+                <a:sym typeface="Calibri"/>
+              </a:rPr>
+              <a:t>0.949</a:t>
+            </a:r>
+            <a:endParaRPr sz="1600"/>
+          </a:p>
+        </p:txBody>
+      </p:sp>
+      <p:sp>
+        <p:nvSpPr>
+          <p:cNvPr id="459" name="Google Shape;459;g3dad1aee3c2_3_0"/>
+          <p:cNvSpPr txBox="1"/>
+          <p:nvPr/>
+        </p:nvSpPr>
+        <p:spPr>
+          <a:xfrm>
+            <a:off x="640080" y="4240275"/>
+            <a:ext cx="4937700" cy="215400"/>
+          </a:xfrm>
+          <a:prstGeom prst="rect">
+            <a:avLst/>
+          </a:prstGeom>
+          <a:noFill/>
+          <a:ln>
+            <a:noFill/>
+          </a:ln>
+        </p:spPr>
+        <p:txBody>
+          <a:bodyPr anchorCtr="0" anchor="t" bIns="0" lIns="0" spcFirstLastPara="1" rIns="0" wrap="square" tIns="0">
+            <a:spAutoFit/>
+          </a:bodyPr>
+          <a:lstStyle/>
+          <a:p>
+            <a:pPr indent="0" lvl="0" marL="0" marR="0" rtl="0" algn="l">
+              <a:lnSpc>
+                <a:spcPct val="100000"/>
+              </a:lnSpc>
+              <a:spcBef>
+                <a:spcPts val="0"/>
+              </a:spcBef>
+              <a:spcAft>
+                <a:spcPts val="0"/>
+              </a:spcAft>
+              <a:buNone/>
+            </a:pPr>
+            <a:r>
+              <a:rPr b="1" i="0" lang="en-US" u="none" cap="none" strike="noStrike">
+                <a:solidFill>
+                  <a:srgbClr val="0F172A"/>
+                </a:solidFill>
+                <a:latin typeface="Calibri"/>
+                <a:ea typeface="Calibri"/>
+                <a:cs typeface="Calibri"/>
+                <a:sym typeface="Calibri"/>
+              </a:rPr>
+              <a:t>HuBERT</a:t>
+            </a:r>
+            <a:r>
+              <a:rPr lang="en-US">
+                <a:solidFill>
+                  <a:srgbClr val="64748B"/>
+                </a:solidFill>
+                <a:latin typeface="Calibri"/>
+                <a:ea typeface="Calibri"/>
+                <a:cs typeface="Calibri"/>
+                <a:sym typeface="Calibri"/>
+              </a:rPr>
+              <a:t>	-	</a:t>
+            </a:r>
+            <a:r>
+              <a:rPr b="1" i="0" lang="en-US" u="none" cap="none" strike="noStrike">
+                <a:solidFill>
+                  <a:srgbClr val="1E2761"/>
+                </a:solidFill>
+                <a:latin typeface="Calibri"/>
+                <a:ea typeface="Calibri"/>
+                <a:cs typeface="Calibri"/>
+                <a:sym typeface="Calibri"/>
+              </a:rPr>
+              <a:t>L8</a:t>
+            </a:r>
+            <a:r>
+              <a:rPr lang="en-US">
+                <a:solidFill>
+                  <a:srgbClr val="64748B"/>
+                </a:solidFill>
+                <a:latin typeface="Calibri"/>
+                <a:ea typeface="Calibri"/>
+                <a:cs typeface="Calibri"/>
+                <a:sym typeface="Calibri"/>
+              </a:rPr>
+              <a:t>	-	</a:t>
+            </a:r>
+            <a:r>
+              <a:rPr b="0" i="0" lang="en-US" u="none" cap="none" strike="noStrike">
+                <a:solidFill>
+                  <a:srgbClr val="64748B"/>
+                </a:solidFill>
+                <a:latin typeface="Calibri"/>
+                <a:ea typeface="Calibri"/>
+                <a:cs typeface="Calibri"/>
+                <a:sym typeface="Calibri"/>
+              </a:rPr>
+              <a:t>acc = </a:t>
+            </a:r>
+            <a:r>
+              <a:rPr b="1" i="0" lang="en-US" u="none" cap="none" strike="noStrike">
+                <a:solidFill>
+                  <a:srgbClr val="0F172A"/>
+                </a:solidFill>
+                <a:latin typeface="Calibri"/>
+                <a:ea typeface="Calibri"/>
+                <a:cs typeface="Calibri"/>
+                <a:sym typeface="Calibri"/>
+              </a:rPr>
+              <a:t>0.947</a:t>
+            </a:r>
+            <a:endParaRPr sz="1600"/>
+          </a:p>
+        </p:txBody>
+      </p:sp>
+      <p:sp>
+        <p:nvSpPr>
+          <p:cNvPr id="460" name="Google Shape;460;g3dad1aee3c2_3_0"/>
+          <p:cNvSpPr txBox="1"/>
+          <p:nvPr/>
+        </p:nvSpPr>
+        <p:spPr>
+          <a:xfrm>
+            <a:off x="640075" y="4517325"/>
+            <a:ext cx="4937700" cy="215400"/>
+          </a:xfrm>
+          <a:prstGeom prst="rect">
+            <a:avLst/>
+          </a:prstGeom>
+          <a:noFill/>
+          <a:ln>
+            <a:noFill/>
+          </a:ln>
+        </p:spPr>
+        <p:txBody>
+          <a:bodyPr anchorCtr="0" anchor="t" bIns="0" lIns="0" spcFirstLastPara="1" rIns="0" wrap="square" tIns="0">
+            <a:spAutoFit/>
+          </a:bodyPr>
+          <a:lstStyle/>
+          <a:p>
+            <a:pPr indent="0" lvl="0" marL="0" marR="0" rtl="0" algn="l">
+              <a:lnSpc>
+                <a:spcPct val="100000"/>
+              </a:lnSpc>
+              <a:spcBef>
+                <a:spcPts val="0"/>
+              </a:spcBef>
+              <a:spcAft>
+                <a:spcPts val="0"/>
+              </a:spcAft>
+              <a:buNone/>
+            </a:pPr>
+            <a:r>
+              <a:rPr b="1" i="0" lang="en-US" u="none" cap="none" strike="noStrike">
+                <a:solidFill>
+                  <a:srgbClr val="0F172A"/>
+                </a:solidFill>
+                <a:latin typeface="Calibri"/>
+                <a:ea typeface="Calibri"/>
+                <a:cs typeface="Calibri"/>
+                <a:sym typeface="Calibri"/>
+              </a:rPr>
+              <a:t>WavLM</a:t>
+            </a:r>
+            <a:r>
+              <a:rPr lang="en-US">
+                <a:solidFill>
+                  <a:srgbClr val="64748B"/>
+                </a:solidFill>
+                <a:latin typeface="Calibri"/>
+                <a:ea typeface="Calibri"/>
+                <a:cs typeface="Calibri"/>
+                <a:sym typeface="Calibri"/>
+              </a:rPr>
+              <a:t>	-	</a:t>
+            </a:r>
+            <a:r>
+              <a:rPr b="1" i="0" lang="en-US" u="none" cap="none" strike="noStrike">
+                <a:solidFill>
+                  <a:srgbClr val="1E2761"/>
+                </a:solidFill>
+                <a:latin typeface="Calibri"/>
+                <a:ea typeface="Calibri"/>
+                <a:cs typeface="Calibri"/>
+                <a:sym typeface="Calibri"/>
+              </a:rPr>
+              <a:t>L6</a:t>
+            </a:r>
+            <a:r>
+              <a:rPr lang="en-US">
+                <a:solidFill>
+                  <a:srgbClr val="64748B"/>
+                </a:solidFill>
+                <a:latin typeface="Calibri"/>
+                <a:ea typeface="Calibri"/>
+                <a:cs typeface="Calibri"/>
+                <a:sym typeface="Calibri"/>
+              </a:rPr>
+              <a:t>	-	</a:t>
+            </a:r>
+            <a:r>
+              <a:rPr b="0" i="0" lang="en-US" u="none" cap="none" strike="noStrike">
+                <a:solidFill>
+                  <a:srgbClr val="64748B"/>
+                </a:solidFill>
+                <a:latin typeface="Calibri"/>
+                <a:ea typeface="Calibri"/>
+                <a:cs typeface="Calibri"/>
+                <a:sym typeface="Calibri"/>
+              </a:rPr>
+              <a:t>acc = </a:t>
+            </a:r>
+            <a:r>
+              <a:rPr b="1" i="0" lang="en-US" u="none" cap="none" strike="noStrike">
+                <a:solidFill>
+                  <a:srgbClr val="0F172A"/>
+                </a:solidFill>
+                <a:latin typeface="Calibri"/>
+                <a:ea typeface="Calibri"/>
+                <a:cs typeface="Calibri"/>
+                <a:sym typeface="Calibri"/>
+              </a:rPr>
+              <a:t>0.945</a:t>
+            </a:r>
+            <a:endParaRPr sz="1600"/>
+          </a:p>
+        </p:txBody>
+      </p:sp>
+      <p:sp>
+        <p:nvSpPr>
+          <p:cNvPr id="461" name="Google Shape;461;g3dad1aee3c2_3_0"/>
+          <p:cNvSpPr txBox="1"/>
+          <p:nvPr/>
+        </p:nvSpPr>
+        <p:spPr>
+          <a:xfrm>
+            <a:off x="640080" y="4741439"/>
+            <a:ext cx="4937700" cy="215400"/>
+          </a:xfrm>
+          <a:prstGeom prst="rect">
+            <a:avLst/>
+          </a:prstGeom>
+          <a:noFill/>
+          <a:ln>
+            <a:noFill/>
+          </a:ln>
+        </p:spPr>
+        <p:txBody>
+          <a:bodyPr anchorCtr="0" anchor="t" bIns="0" lIns="0" spcFirstLastPara="1" rIns="0" wrap="square" tIns="0">
+            <a:spAutoFit/>
+          </a:bodyPr>
+          <a:lstStyle/>
+          <a:p>
+            <a:pPr indent="0" lvl="0" marL="0" marR="0" rtl="0" algn="l">
+              <a:lnSpc>
+                <a:spcPct val="100000"/>
+              </a:lnSpc>
+              <a:spcBef>
+                <a:spcPts val="0"/>
+              </a:spcBef>
+              <a:spcAft>
+                <a:spcPts val="0"/>
+              </a:spcAft>
+              <a:buNone/>
+            </a:pPr>
+            <a:r>
+              <a:rPr b="1" i="0" lang="en-US" u="none" cap="none" strike="noStrike">
+                <a:solidFill>
+                  <a:srgbClr val="0F172A"/>
+                </a:solidFill>
+                <a:latin typeface="Calibri"/>
+                <a:ea typeface="Calibri"/>
+                <a:cs typeface="Calibri"/>
+                <a:sym typeface="Calibri"/>
+              </a:rPr>
+              <a:t>w2v-BERT</a:t>
+            </a:r>
+            <a:r>
+              <a:rPr lang="en-US">
+                <a:solidFill>
+                  <a:srgbClr val="64748B"/>
+                </a:solidFill>
+                <a:latin typeface="Calibri"/>
+                <a:ea typeface="Calibri"/>
+                <a:cs typeface="Calibri"/>
+                <a:sym typeface="Calibri"/>
+              </a:rPr>
+              <a:t>	-	</a:t>
+            </a:r>
+            <a:r>
+              <a:rPr b="1" i="0" lang="en-US" u="none" cap="none" strike="noStrike">
+                <a:solidFill>
+                  <a:srgbClr val="1E2761"/>
+                </a:solidFill>
+                <a:latin typeface="Calibri"/>
+                <a:ea typeface="Calibri"/>
+                <a:cs typeface="Calibri"/>
+                <a:sym typeface="Calibri"/>
+              </a:rPr>
+              <a:t>L17</a:t>
+            </a:r>
+            <a:r>
+              <a:rPr lang="en-US">
+                <a:solidFill>
+                  <a:srgbClr val="64748B"/>
+                </a:solidFill>
+                <a:latin typeface="Calibri"/>
+                <a:ea typeface="Calibri"/>
+                <a:cs typeface="Calibri"/>
+                <a:sym typeface="Calibri"/>
+              </a:rPr>
+              <a:t>	-	</a:t>
+            </a:r>
+            <a:r>
+              <a:rPr b="0" i="0" lang="en-US" u="none" cap="none" strike="noStrike">
+                <a:solidFill>
+                  <a:srgbClr val="64748B"/>
+                </a:solidFill>
+                <a:latin typeface="Calibri"/>
+                <a:ea typeface="Calibri"/>
+                <a:cs typeface="Calibri"/>
+                <a:sym typeface="Calibri"/>
+              </a:rPr>
+              <a:t>acc = </a:t>
+            </a:r>
+            <a:r>
+              <a:rPr b="1" i="0" lang="en-US" u="none" cap="none" strike="noStrike">
+                <a:solidFill>
+                  <a:srgbClr val="0F172A"/>
+                </a:solidFill>
+                <a:latin typeface="Calibri"/>
+                <a:ea typeface="Calibri"/>
+                <a:cs typeface="Calibri"/>
+                <a:sym typeface="Calibri"/>
+              </a:rPr>
+              <a:t>0.936</a:t>
+            </a:r>
+            <a:endParaRPr sz="1600"/>
+          </a:p>
+        </p:txBody>
+      </p:sp>
+      <p:sp>
+        <p:nvSpPr>
+          <p:cNvPr id="462" name="Google Shape;462;g3dad1aee3c2_3_0"/>
+          <p:cNvSpPr txBox="1"/>
+          <p:nvPr/>
+        </p:nvSpPr>
+        <p:spPr>
+          <a:xfrm>
+            <a:off x="640080" y="5008371"/>
+            <a:ext cx="4937700" cy="215400"/>
+          </a:xfrm>
+          <a:prstGeom prst="rect">
+            <a:avLst/>
+          </a:prstGeom>
+          <a:noFill/>
+          <a:ln>
+            <a:noFill/>
+          </a:ln>
+        </p:spPr>
+        <p:txBody>
+          <a:bodyPr anchorCtr="0" anchor="t" bIns="0" lIns="0" spcFirstLastPara="1" rIns="0" wrap="square" tIns="0">
+            <a:spAutoFit/>
+          </a:bodyPr>
+          <a:lstStyle/>
+          <a:p>
+            <a:pPr indent="0" lvl="0" marL="0" marR="0" rtl="0" algn="l">
+              <a:lnSpc>
+                <a:spcPct val="100000"/>
+              </a:lnSpc>
+              <a:spcBef>
+                <a:spcPts val="0"/>
+              </a:spcBef>
+              <a:spcAft>
+                <a:spcPts val="0"/>
+              </a:spcAft>
+              <a:buNone/>
+            </a:pPr>
+            <a:r>
+              <a:rPr b="1" i="0" lang="en-US" u="none" cap="none" strike="noStrike">
+                <a:solidFill>
+                  <a:srgbClr val="0F172A"/>
+                </a:solidFill>
+                <a:latin typeface="Calibri"/>
+                <a:ea typeface="Calibri"/>
+                <a:cs typeface="Calibri"/>
+                <a:sym typeface="Calibri"/>
+              </a:rPr>
+              <a:t>wav2vec2</a:t>
+            </a:r>
+            <a:r>
+              <a:rPr lang="en-US">
+                <a:solidFill>
+                  <a:srgbClr val="64748B"/>
+                </a:solidFill>
+                <a:latin typeface="Calibri"/>
+                <a:ea typeface="Calibri"/>
+                <a:cs typeface="Calibri"/>
+                <a:sym typeface="Calibri"/>
+              </a:rPr>
+              <a:t>	-	</a:t>
+            </a:r>
+            <a:r>
+              <a:rPr b="1" i="0" lang="en-US" u="none" cap="none" strike="noStrike">
+                <a:solidFill>
+                  <a:srgbClr val="1E2761"/>
+                </a:solidFill>
+                <a:latin typeface="Calibri"/>
+                <a:ea typeface="Calibri"/>
+                <a:cs typeface="Calibri"/>
+                <a:sym typeface="Calibri"/>
+              </a:rPr>
+              <a:t>L8</a:t>
+            </a:r>
+            <a:r>
+              <a:rPr lang="en-US">
+                <a:solidFill>
+                  <a:srgbClr val="64748B"/>
+                </a:solidFill>
+                <a:latin typeface="Calibri"/>
+                <a:ea typeface="Calibri"/>
+                <a:cs typeface="Calibri"/>
+                <a:sym typeface="Calibri"/>
+              </a:rPr>
+              <a:t>	-	</a:t>
+            </a:r>
+            <a:r>
+              <a:rPr b="0" i="0" lang="en-US" u="none" cap="none" strike="noStrike">
+                <a:solidFill>
+                  <a:srgbClr val="64748B"/>
+                </a:solidFill>
+                <a:latin typeface="Calibri"/>
+                <a:ea typeface="Calibri"/>
+                <a:cs typeface="Calibri"/>
+                <a:sym typeface="Calibri"/>
+              </a:rPr>
+              <a:t>acc = </a:t>
+            </a:r>
+            <a:r>
+              <a:rPr b="1" i="0" lang="en-US" u="none" cap="none" strike="noStrike">
+                <a:solidFill>
+                  <a:srgbClr val="0F172A"/>
+                </a:solidFill>
+                <a:latin typeface="Calibri"/>
+                <a:ea typeface="Calibri"/>
+                <a:cs typeface="Calibri"/>
+                <a:sym typeface="Calibri"/>
+              </a:rPr>
+              <a:t>0.922</a:t>
+            </a:r>
+            <a:endParaRPr sz="1600"/>
+          </a:p>
+        </p:txBody>
+      </p:sp>
+      <p:sp>
+        <p:nvSpPr>
+          <p:cNvPr id="463" name="Google Shape;463;g3dad1aee3c2_3_0"/>
+          <p:cNvSpPr txBox="1"/>
+          <p:nvPr/>
+        </p:nvSpPr>
+        <p:spPr>
+          <a:xfrm>
+            <a:off x="640080" y="5264403"/>
+            <a:ext cx="4937700" cy="215400"/>
+          </a:xfrm>
+          <a:prstGeom prst="rect">
+            <a:avLst/>
+          </a:prstGeom>
+          <a:noFill/>
+          <a:ln>
+            <a:noFill/>
+          </a:ln>
+        </p:spPr>
+        <p:txBody>
+          <a:bodyPr anchorCtr="0" anchor="t" bIns="0" lIns="0" spcFirstLastPara="1" rIns="0" wrap="square" tIns="0">
+            <a:spAutoFit/>
+          </a:bodyPr>
+          <a:lstStyle/>
+          <a:p>
+            <a:pPr indent="0" lvl="0" marL="0" marR="0" rtl="0" algn="l">
+              <a:lnSpc>
+                <a:spcPct val="100000"/>
+              </a:lnSpc>
+              <a:spcBef>
+                <a:spcPts val="0"/>
+              </a:spcBef>
+              <a:spcAft>
+                <a:spcPts val="0"/>
+              </a:spcAft>
+              <a:buNone/>
+            </a:pPr>
+            <a:r>
+              <a:rPr b="1" i="0" lang="en-US" u="none" cap="none" strike="noStrike">
+                <a:solidFill>
+                  <a:srgbClr val="0F172A"/>
+                </a:solidFill>
+                <a:latin typeface="Calibri"/>
+                <a:ea typeface="Calibri"/>
+                <a:cs typeface="Calibri"/>
+                <a:sym typeface="Calibri"/>
+              </a:rPr>
+              <a:t>MERT</a:t>
+            </a:r>
+            <a:r>
+              <a:rPr lang="en-US">
+                <a:solidFill>
+                  <a:srgbClr val="64748B"/>
+                </a:solidFill>
+                <a:latin typeface="Calibri"/>
+                <a:ea typeface="Calibri"/>
+                <a:cs typeface="Calibri"/>
+                <a:sym typeface="Calibri"/>
+              </a:rPr>
+              <a:t>		-	</a:t>
+            </a:r>
+            <a:r>
+              <a:rPr b="1" i="0" lang="en-US" u="none" cap="none" strike="noStrike">
+                <a:solidFill>
+                  <a:srgbClr val="1E2761"/>
+                </a:solidFill>
+                <a:latin typeface="Calibri"/>
+                <a:ea typeface="Calibri"/>
+                <a:cs typeface="Calibri"/>
+                <a:sym typeface="Calibri"/>
+              </a:rPr>
+              <a:t>L5</a:t>
+            </a:r>
+            <a:r>
+              <a:rPr lang="en-US">
+                <a:solidFill>
+                  <a:srgbClr val="64748B"/>
+                </a:solidFill>
+                <a:latin typeface="Calibri"/>
+                <a:ea typeface="Calibri"/>
+                <a:cs typeface="Calibri"/>
+                <a:sym typeface="Calibri"/>
+              </a:rPr>
+              <a:t>	-	</a:t>
+            </a:r>
+            <a:r>
+              <a:rPr b="0" i="0" lang="en-US" u="none" cap="none" strike="noStrike">
+                <a:solidFill>
+                  <a:srgbClr val="64748B"/>
+                </a:solidFill>
+                <a:latin typeface="Calibri"/>
+                <a:ea typeface="Calibri"/>
+                <a:cs typeface="Calibri"/>
+                <a:sym typeface="Calibri"/>
+              </a:rPr>
+              <a:t>acc = </a:t>
+            </a:r>
+            <a:r>
+              <a:rPr b="1" i="0" lang="en-US" u="none" cap="none" strike="noStrike">
+                <a:solidFill>
+                  <a:srgbClr val="0F172A"/>
+                </a:solidFill>
+                <a:latin typeface="Calibri"/>
+                <a:ea typeface="Calibri"/>
+                <a:cs typeface="Calibri"/>
+                <a:sym typeface="Calibri"/>
+              </a:rPr>
+              <a:t>0.907</a:t>
+            </a:r>
+            <a:endParaRPr sz="1600"/>
+          </a:p>
+        </p:txBody>
+      </p:sp>
+      <p:sp>
+        <p:nvSpPr>
+          <p:cNvPr id="464" name="Google Shape;464;g3dad1aee3c2_3_0"/>
+          <p:cNvSpPr txBox="1"/>
+          <p:nvPr/>
+        </p:nvSpPr>
+        <p:spPr>
+          <a:xfrm>
+            <a:off x="640080" y="5618493"/>
+            <a:ext cx="4937700" cy="369300"/>
+          </a:xfrm>
+          <a:prstGeom prst="rect">
+            <a:avLst/>
+          </a:prstGeom>
+          <a:noFill/>
+          <a:ln>
+            <a:noFill/>
+          </a:ln>
+        </p:spPr>
+        <p:txBody>
+          <a:bodyPr anchorCtr="0" anchor="t" bIns="0" lIns="0" spcFirstLastPara="1" rIns="0" wrap="square" tIns="0">
+            <a:spAutoFit/>
+          </a:bodyPr>
+          <a:lstStyle/>
+          <a:p>
+            <a:pPr indent="0" lvl="0" marL="0" marR="0" rtl="0" algn="l">
+              <a:lnSpc>
+                <a:spcPct val="100000"/>
+              </a:lnSpc>
+              <a:spcBef>
+                <a:spcPts val="0"/>
+              </a:spcBef>
+              <a:spcAft>
+                <a:spcPts val="0"/>
+              </a:spcAft>
+              <a:buNone/>
+            </a:pPr>
+            <a:r>
+              <a:rPr b="1" i="0" lang="en-US" sz="1200" u="none" cap="none" strike="noStrike">
+                <a:solidFill>
+                  <a:srgbClr val="1E2761"/>
+                </a:solidFill>
+                <a:latin typeface="Calibri"/>
+                <a:ea typeface="Calibri"/>
+                <a:cs typeface="Calibri"/>
+                <a:sym typeface="Calibri"/>
+              </a:rPr>
+              <a:t>Highlights: </a:t>
+            </a:r>
+            <a:r>
+              <a:rPr b="1" i="0" lang="en-US" sz="1200" u="none" cap="none" strike="noStrike">
+                <a:solidFill>
+                  <a:srgbClr val="64748B"/>
+                </a:solidFill>
+                <a:latin typeface="Calibri"/>
+                <a:ea typeface="Calibri"/>
+                <a:cs typeface="Calibri"/>
+                <a:sym typeface="Calibri"/>
+              </a:rPr>
+              <a:t>Spanish held-out collapses (HuBERT 0.38, MERT 0.41); German held-out stays ≥0.88 across all 6 models.</a:t>
+            </a:r>
+            <a:endParaRPr b="1" sz="1500"/>
+          </a:p>
+        </p:txBody>
+      </p:sp>
+      <p:pic>
+        <p:nvPicPr>
+          <p:cNvPr descr="speechcraft_summary_bar.png" id="465" name="Google Shape;465;g3dad1aee3c2_3_0"/>
+          <p:cNvPicPr preferRelativeResize="0"/>
+          <p:nvPr/>
+        </p:nvPicPr>
+        <p:blipFill rotWithShape="1">
+          <a:blip r:embed="rId3">
+            <a:alphaModFix/>
+          </a:blip>
+          <a:srcRect b="0" l="0" r="0" t="0"/>
+          <a:stretch/>
+        </p:blipFill>
+        <p:spPr>
+          <a:xfrm>
+            <a:off x="5806440" y="1783080"/>
+            <a:ext cx="6080760" cy="3520440"/>
+          </a:xfrm>
+          <a:prstGeom prst="rect">
+            <a:avLst/>
+          </a:prstGeom>
+          <a:noFill/>
+          <a:ln>
+            <a:noFill/>
+          </a:ln>
+        </p:spPr>
+      </p:pic>
+      <p:sp>
+        <p:nvSpPr>
+          <p:cNvPr id="466" name="Google Shape;466;g3dad1aee3c2_3_0"/>
+          <p:cNvSpPr txBox="1"/>
+          <p:nvPr/>
+        </p:nvSpPr>
+        <p:spPr>
+          <a:xfrm>
+            <a:off x="5806440" y="5349240"/>
+            <a:ext cx="6126480" cy="201168"/>
+          </a:xfrm>
+          <a:prstGeom prst="rect">
+            <a:avLst/>
+          </a:prstGeom>
+          <a:noFill/>
+          <a:ln>
+            <a:noFill/>
+          </a:ln>
+        </p:spPr>
+        <p:txBody>
+          <a:bodyPr anchorCtr="0" anchor="t" bIns="0" lIns="0" spcFirstLastPara="1" rIns="0" wrap="square" tIns="0">
+            <a:spAutoFit/>
+          </a:bodyPr>
+          <a:lstStyle/>
+          <a:p>
+            <a:pPr indent="0" lvl="0" marL="0" marR="0" rtl="0" algn="l">
+              <a:lnSpc>
+                <a:spcPct val="100000"/>
+              </a:lnSpc>
+              <a:spcBef>
+                <a:spcPts val="0"/>
+              </a:spcBef>
+              <a:spcAft>
+                <a:spcPts val="0"/>
+              </a:spcAft>
+              <a:buNone/>
+            </a:pPr>
+            <a:r>
+              <a:rPr b="0" i="0" lang="en-US" sz="1200" u="none" cap="none" strike="noStrike">
+                <a:solidFill>
+                  <a:srgbClr val="64748B"/>
+                </a:solidFill>
+                <a:latin typeface="Calibri"/>
+                <a:ea typeface="Calibri"/>
+                <a:cs typeface="Calibri"/>
+                <a:sym typeface="Calibri"/>
+              </a:rPr>
+              <a:t>Per-encoder best-layer accuracy: pooled CV (gray) vs each held-out language (colored).</a:t>
+            </a:r>
+            <a:endParaRPr/>
+          </a:p>
+        </p:txBody>
+      </p:sp>
+      <p:sp>
+        <p:nvSpPr>
+          <p:cNvPr id="467" name="Google Shape;467;g3dad1aee3c2_3_0"/>
           <p:cNvSpPr/>
           <p:nvPr/>
         </p:nvSpPr>
         <p:spPr>
           <a:xfrm>
-            <a:off x="502920" y="1783080"/>
-            <a:ext cx="3618900" cy="2834700"/>
+            <a:off x="5806440" y="5623560"/>
+            <a:ext cx="1417320" cy="384048"/>
           </a:xfrm>
           <a:prstGeom prst="roundRect">
             <a:avLst>
-              <a:gd fmla="val 4000" name="adj"/>
+              <a:gd fmla="val 16667" name="adj"/>
             </a:avLst>
           </a:prstGeom>
           <a:solidFill>
-            <a:srgbClr val="FFFFFF"/>
+            <a:srgbClr val="2A6F97"/>
           </a:solidFill>
-          <a:ln cap="flat" cmpd="sng" w="12700">
-            <a:solidFill>
-              <a:srgbClr val="D5DBE8"/>
-            </a:solidFill>
-            <a:prstDash val="solid"/>
-            <a:round/>
-            <a:headEnd len="sm" w="sm" type="none"/>
-            <a:tailEnd len="sm" w="sm" type="none"/>
+          <a:ln>
+            <a:noFill/>
           </a:ln>
         </p:spPr>
         <p:txBody>
@@ -8641,20 +10227,102 @@
       </p:sp>
       <p:sp>
         <p:nvSpPr>
-          <p:cNvPr id="451" name="Google Shape;451;g3dab19ec515_10_254"/>
+          <p:cNvPr id="468" name="Google Shape;468;g3dad1aee3c2_3_0"/>
+          <p:cNvSpPr txBox="1"/>
+          <p:nvPr/>
+        </p:nvSpPr>
+        <p:spPr>
+          <a:xfrm>
+            <a:off x="5897879" y="5669280"/>
+            <a:ext cx="1234440" cy="292607"/>
+          </a:xfrm>
+          <a:prstGeom prst="rect">
+            <a:avLst/>
+          </a:prstGeom>
+          <a:noFill/>
+          <a:ln>
+            <a:noFill/>
+          </a:ln>
+        </p:spPr>
+        <p:txBody>
+          <a:bodyPr anchorCtr="0" anchor="ctr" bIns="0" lIns="0" spcFirstLastPara="1" rIns="0" wrap="square" tIns="0">
+            <a:spAutoFit/>
+          </a:bodyPr>
+          <a:lstStyle/>
+          <a:p>
+            <a:pPr indent="0" lvl="0" marL="0" marR="0" rtl="0" algn="l">
+              <a:lnSpc>
+                <a:spcPct val="105000"/>
+              </a:lnSpc>
+              <a:spcBef>
+                <a:spcPts val="0"/>
+              </a:spcBef>
+              <a:spcAft>
+                <a:spcPts val="0"/>
+              </a:spcAft>
+              <a:buNone/>
+            </a:pPr>
+            <a:r>
+              <a:rPr b="1" i="0" lang="en-US" sz="1200" u="none" cap="none" strike="noStrike">
+                <a:solidFill>
+                  <a:srgbClr val="FFFFFF"/>
+                </a:solidFill>
+                <a:latin typeface="Calibri"/>
+                <a:ea typeface="Calibri"/>
+                <a:cs typeface="Calibri"/>
+                <a:sym typeface="Calibri"/>
+              </a:rPr>
+              <a:t>German</a:t>
+            </a:r>
+            <a:endParaRPr/>
+          </a:p>
+          <a:p>
+            <a:pPr indent="0" lvl="0" marL="0" marR="0" rtl="0" algn="l">
+              <a:lnSpc>
+                <a:spcPct val="105000"/>
+              </a:lnSpc>
+              <a:spcBef>
+                <a:spcPts val="0"/>
+              </a:spcBef>
+              <a:spcAft>
+                <a:spcPts val="0"/>
+              </a:spcAft>
+              <a:buNone/>
+            </a:pPr>
+            <a:r>
+              <a:rPr b="0" i="0" lang="en-US" sz="1100" u="none" cap="none" strike="noStrike">
+                <a:solidFill>
+                  <a:srgbClr val="FFFFFF"/>
+                </a:solidFill>
+                <a:latin typeface="Calibri"/>
+                <a:ea typeface="Calibri"/>
+                <a:cs typeface="Calibri"/>
+                <a:sym typeface="Calibri"/>
+              </a:rPr>
+              <a:t>0.88 – 0.95</a:t>
+            </a:r>
+            <a:endParaRPr/>
+          </a:p>
+        </p:txBody>
+      </p:sp>
+      <p:sp>
+        <p:nvSpPr>
+          <p:cNvPr id="469" name="Google Shape;469;g3dad1aee3c2_3_0"/>
           <p:cNvSpPr/>
           <p:nvPr/>
         </p:nvSpPr>
         <p:spPr>
           <a:xfrm>
-            <a:off x="502920" y="1783080"/>
-            <a:ext cx="3618900" cy="91500"/>
-          </a:xfrm>
-          <a:prstGeom prst="rect">
-            <a:avLst/>
+            <a:off x="7315199" y="5623560"/>
+            <a:ext cx="1417320" cy="384048"/>
+          </a:xfrm>
+          <a:prstGeom prst="roundRect">
+            <a:avLst>
+              <a:gd fmla="val 16667" name="adj"/>
+            </a:avLst>
           </a:prstGeom>
           <a:solidFill>
-            <a:srgbClr val="1A2A57"/>
+            <a:srgbClr val="2A6F97"/>
           </a:solidFill>
           <a:ln>
             <a:noFill/>
@@ -8695,32 +10363,32 @@
       </p:sp>
       <p:sp>
         <p:nvSpPr>
-          <p:cNvPr id="452" name="Google Shape;452;g3dab19ec515_10_254"/>
+          <p:cNvPr id="470" name="Google Shape;470;g3dad1aee3c2_3_0"/>
           <p:cNvSpPr txBox="1"/>
           <p:nvPr/>
         </p:nvSpPr>
         <p:spPr>
           <a:xfrm>
-            <a:off x="777240" y="2057400"/>
-            <a:ext cx="3070200" cy="184800"/>
-          </a:xfrm>
-          <a:prstGeom prst="rect">
-            <a:avLst/>
-          </a:prstGeom>
-          <a:noFill/>
-          <a:ln>
-            <a:noFill/>
-          </a:ln>
-        </p:spPr>
-        <p:txBody>
-          <a:bodyPr anchorCtr="0" anchor="t" bIns="0" lIns="0" spcFirstLastPara="1" rIns="0" wrap="square" tIns="0">
+            <a:off x="7406640" y="5669280"/>
+            <a:ext cx="1234440" cy="292607"/>
+          </a:xfrm>
+          <a:prstGeom prst="rect">
+            <a:avLst/>
+          </a:prstGeom>
+          <a:noFill/>
+          <a:ln>
+            <a:noFill/>
+          </a:ln>
+        </p:spPr>
+        <p:txBody>
+          <a:bodyPr anchorCtr="0" anchor="ctr" bIns="0" lIns="0" spcFirstLastPara="1" rIns="0" wrap="square" tIns="0">
             <a:spAutoFit/>
           </a:bodyPr>
           <a:lstStyle/>
           <a:p>
             <a:pPr indent="0" lvl="0" marL="0" marR="0" rtl="0" algn="l">
               <a:lnSpc>
-                <a:spcPct val="115000"/>
+                <a:spcPct val="105000"/>
               </a:lnSpc>
               <a:spcBef>
                 <a:spcPts val="0"/>
@@ -8733,152 +10401,67 @@
             <a:r>
               <a:rPr b="1" i="0" lang="en-US" sz="1200" u="none" cap="none" strike="noStrike">
                 <a:solidFill>
-                  <a:srgbClr val="6B7280"/>
-                </a:solidFill>
-                <a:latin typeface="Calibri"/>
-                <a:ea typeface="Calibri"/>
-                <a:cs typeface="Calibri"/>
-                <a:sym typeface="Calibri"/>
-              </a:rPr>
-              <a:t>WHERE</a:t>
-            </a:r>
-            <a:endParaRPr b="1" sz="1500"/>
-          </a:p>
-        </p:txBody>
-      </p:sp>
-      <p:sp>
-        <p:nvSpPr>
-          <p:cNvPr id="453" name="Google Shape;453;g3dab19ec515_10_254"/>
-          <p:cNvSpPr txBox="1"/>
-          <p:nvPr/>
-        </p:nvSpPr>
-        <p:spPr>
-          <a:xfrm>
-            <a:off x="777240" y="2377440"/>
-            <a:ext cx="3070200" cy="354000"/>
-          </a:xfrm>
-          <a:prstGeom prst="rect">
-            <a:avLst/>
-          </a:prstGeom>
-          <a:noFill/>
-          <a:ln>
-            <a:noFill/>
-          </a:ln>
-        </p:spPr>
-        <p:txBody>
-          <a:bodyPr anchorCtr="0" anchor="t" bIns="0" lIns="0" spcFirstLastPara="1" rIns="0" wrap="square" tIns="0">
-            <a:spAutoFit/>
-          </a:bodyPr>
-          <a:lstStyle/>
+                  <a:srgbClr val="FFFFFF"/>
+                </a:solidFill>
+                <a:latin typeface="Calibri"/>
+                <a:ea typeface="Calibri"/>
+                <a:cs typeface="Calibri"/>
+                <a:sym typeface="Calibri"/>
+              </a:rPr>
+              <a:t>Greek</a:t>
+            </a:r>
+            <a:endParaRPr/>
+          </a:p>
           <a:p>
             <a:pPr indent="0" lvl="0" marL="0" marR="0" rtl="0" algn="l">
               <a:lnSpc>
-                <a:spcPct val="110000"/>
-              </a:lnSpc>
-              <a:spcBef>
-                <a:spcPts val="0"/>
-              </a:spcBef>
-              <a:spcAft>
-                <a:spcPts val="0"/>
-              </a:spcAft>
-              <a:buNone/>
-            </a:pPr>
-            <a:r>
-              <a:rPr b="1" i="0" lang="en-US" sz="2300" u="none" cap="none" strike="noStrike">
-                <a:solidFill>
-                  <a:srgbClr val="1A2A57"/>
-                </a:solidFill>
-                <a:latin typeface="Calibri"/>
-                <a:ea typeface="Calibri"/>
-                <a:cs typeface="Calibri"/>
-                <a:sym typeface="Calibri"/>
-              </a:rPr>
-              <a:t>Middle-to-late layers</a:t>
-            </a:r>
-            <a:endParaRPr sz="1500"/>
-          </a:p>
-        </p:txBody>
-      </p:sp>
-      <p:sp>
-        <p:nvSpPr>
-          <p:cNvPr id="454" name="Google Shape;454;g3dab19ec515_10_254"/>
-          <p:cNvSpPr txBox="1"/>
-          <p:nvPr/>
-        </p:nvSpPr>
-        <p:spPr>
-          <a:xfrm>
-            <a:off x="777265" y="2945188"/>
-            <a:ext cx="3070200" cy="1379100"/>
-          </a:xfrm>
-          <a:prstGeom prst="rect">
-            <a:avLst/>
-          </a:prstGeom>
-          <a:noFill/>
-          <a:ln>
-            <a:noFill/>
-          </a:ln>
-        </p:spPr>
-        <p:txBody>
-          <a:bodyPr anchorCtr="0" anchor="t" bIns="0" lIns="0" spcFirstLastPara="1" rIns="0" wrap="square" tIns="0">
-            <a:spAutoFit/>
-          </a:bodyPr>
-          <a:lstStyle/>
-          <a:p>
-            <a:pPr indent="0" lvl="0" marL="0" marR="0" rtl="0" algn="l">
-              <a:lnSpc>
-                <a:spcPct val="135000"/>
-              </a:lnSpc>
-              <a:spcBef>
-                <a:spcPts val="0"/>
-              </a:spcBef>
-              <a:spcAft>
-                <a:spcPts val="0"/>
-              </a:spcAft>
-              <a:buNone/>
-            </a:pPr>
-            <a:r>
-              <a:rPr b="1" i="0" lang="en-US" u="none" cap="none" strike="noStrike">
-                <a:solidFill>
-                  <a:srgbClr val="404755"/>
-                </a:solidFill>
-                <a:latin typeface="Calibri"/>
-                <a:ea typeface="Calibri"/>
-                <a:cs typeface="Calibri"/>
-                <a:sym typeface="Calibri"/>
-              </a:rPr>
-              <a:t>Emotion is encoded in the same layer band across all 6 encoders, 9 corpora, 7 languages. Wav2vec2's deep layers collapse; HuBERT, WavLM, Whisper retain emotion deeper.</a:t>
-            </a:r>
-            <a:endParaRPr b="1" sz="1500"/>
-          </a:p>
-        </p:txBody>
-      </p:sp>
-      <p:sp>
-        <p:nvSpPr>
-          <p:cNvPr id="455" name="Google Shape;455;g3dab19ec515_10_254"/>
+                <a:spcPct val="105000"/>
+              </a:lnSpc>
+              <a:spcBef>
+                <a:spcPts val="0"/>
+              </a:spcBef>
+              <a:spcAft>
+                <a:spcPts val="0"/>
+              </a:spcAft>
+              <a:buNone/>
+            </a:pPr>
+            <a:r>
+              <a:rPr b="0" i="0" lang="en-US" sz="1100" u="none" cap="none" strike="noStrike">
+                <a:solidFill>
+                  <a:srgbClr val="FFFFFF"/>
+                </a:solidFill>
+                <a:latin typeface="Calibri"/>
+                <a:ea typeface="Calibri"/>
+                <a:cs typeface="Calibri"/>
+                <a:sym typeface="Calibri"/>
+              </a:rPr>
+              <a:t>0.55 – 0.76</a:t>
+            </a:r>
+            <a:endParaRPr/>
+          </a:p>
+        </p:txBody>
+      </p:sp>
+      <p:sp>
+        <p:nvSpPr>
+          <p:cNvPr id="471" name="Google Shape;471;g3dad1aee3c2_3_0"/>
           <p:cNvSpPr/>
           <p:nvPr/>
         </p:nvSpPr>
         <p:spPr>
           <a:xfrm>
-            <a:off x="4286402" y="1783080"/>
-            <a:ext cx="3618900" cy="2834700"/>
+            <a:off x="8823960" y="5623560"/>
+            <a:ext cx="1417320" cy="384048"/>
           </a:xfrm>
           <a:prstGeom prst="roundRect">
             <a:avLst>
-              <a:gd fmla="val 4000" name="adj"/>
+              <a:gd fmla="val 16667" name="adj"/>
             </a:avLst>
           </a:prstGeom>
           <a:solidFill>
-            <a:srgbClr val="FFFFFF"/>
+            <a:srgbClr val="2A6F97"/>
           </a:solidFill>
-          <a:ln cap="flat" cmpd="sng" w="12700">
-            <a:solidFill>
-              <a:srgbClr val="D5DBE8"/>
-            </a:solidFill>
-            <a:prstDash val="solid"/>
-            <a:round/>
-            <a:headEnd len="sm" w="sm" type="none"/>
-            <a:tailEnd len="sm" w="sm" type="none"/>
+          <a:ln>
+            <a:noFill/>
           </a:ln>
         </p:spPr>
         <p:txBody>
@@ -8916,20 +10499,102 @@
       </p:sp>
       <p:sp>
         <p:nvSpPr>
-          <p:cNvPr id="456" name="Google Shape;456;g3dab19ec515_10_254"/>
+          <p:cNvPr id="472" name="Google Shape;472;g3dad1aee3c2_3_0"/>
+          <p:cNvSpPr txBox="1"/>
+          <p:nvPr/>
+        </p:nvSpPr>
+        <p:spPr>
+          <a:xfrm>
+            <a:off x="8915400" y="5669280"/>
+            <a:ext cx="1234440" cy="292607"/>
+          </a:xfrm>
+          <a:prstGeom prst="rect">
+            <a:avLst/>
+          </a:prstGeom>
+          <a:noFill/>
+          <a:ln>
+            <a:noFill/>
+          </a:ln>
+        </p:spPr>
+        <p:txBody>
+          <a:bodyPr anchorCtr="0" anchor="ctr" bIns="0" lIns="0" spcFirstLastPara="1" rIns="0" wrap="square" tIns="0">
+            <a:spAutoFit/>
+          </a:bodyPr>
+          <a:lstStyle/>
+          <a:p>
+            <a:pPr indent="0" lvl="0" marL="0" marR="0" rtl="0" algn="l">
+              <a:lnSpc>
+                <a:spcPct val="105000"/>
+              </a:lnSpc>
+              <a:spcBef>
+                <a:spcPts val="0"/>
+              </a:spcBef>
+              <a:spcAft>
+                <a:spcPts val="0"/>
+              </a:spcAft>
+              <a:buNone/>
+            </a:pPr>
+            <a:r>
+              <a:rPr b="1" i="0" lang="en-US" sz="1200" u="none" cap="none" strike="noStrike">
+                <a:solidFill>
+                  <a:srgbClr val="FFFFFF"/>
+                </a:solidFill>
+                <a:latin typeface="Calibri"/>
+                <a:ea typeface="Calibri"/>
+                <a:cs typeface="Calibri"/>
+                <a:sym typeface="Calibri"/>
+              </a:rPr>
+              <a:t>English</a:t>
+            </a:r>
+            <a:endParaRPr/>
+          </a:p>
+          <a:p>
+            <a:pPr indent="0" lvl="0" marL="0" marR="0" rtl="0" algn="l">
+              <a:lnSpc>
+                <a:spcPct val="105000"/>
+              </a:lnSpc>
+              <a:spcBef>
+                <a:spcPts val="0"/>
+              </a:spcBef>
+              <a:spcAft>
+                <a:spcPts val="0"/>
+              </a:spcAft>
+              <a:buNone/>
+            </a:pPr>
+            <a:r>
+              <a:rPr b="0" i="0" lang="en-US" sz="1100" u="none" cap="none" strike="noStrike">
+                <a:solidFill>
+                  <a:srgbClr val="FFFFFF"/>
+                </a:solidFill>
+                <a:latin typeface="Calibri"/>
+                <a:ea typeface="Calibri"/>
+                <a:cs typeface="Calibri"/>
+                <a:sym typeface="Calibri"/>
+              </a:rPr>
+              <a:t>0.59 – 0.74</a:t>
+            </a:r>
+            <a:endParaRPr/>
+          </a:p>
+        </p:txBody>
+      </p:sp>
+      <p:sp>
+        <p:nvSpPr>
+          <p:cNvPr id="473" name="Google Shape;473;g3dad1aee3c2_3_0"/>
           <p:cNvSpPr/>
           <p:nvPr/>
         </p:nvSpPr>
         <p:spPr>
           <a:xfrm>
-            <a:off x="4286402" y="1783080"/>
-            <a:ext cx="3618900" cy="91500"/>
-          </a:xfrm>
-          <a:prstGeom prst="rect">
-            <a:avLst/>
+            <a:off x="10332720" y="5623560"/>
+            <a:ext cx="1417320" cy="384048"/>
+          </a:xfrm>
+          <a:prstGeom prst="roundRect">
+            <a:avLst>
+              <a:gd fmla="val 16667" name="adj"/>
+            </a:avLst>
           </a:prstGeom>
           <a:solidFill>
-            <a:srgbClr val="E8924A"/>
+            <a:srgbClr val="B85042"/>
           </a:solidFill>
           <a:ln>
             <a:noFill/>
@@ -8970,32 +10635,32 @@
       </p:sp>
       <p:sp>
         <p:nvSpPr>
-          <p:cNvPr id="457" name="Google Shape;457;g3dab19ec515_10_254"/>
+          <p:cNvPr id="474" name="Google Shape;474;g3dad1aee3c2_3_0"/>
           <p:cNvSpPr txBox="1"/>
           <p:nvPr/>
         </p:nvSpPr>
         <p:spPr>
           <a:xfrm>
-            <a:off x="4560722" y="2057400"/>
-            <a:ext cx="3070200" cy="184800"/>
-          </a:xfrm>
-          <a:prstGeom prst="rect">
-            <a:avLst/>
-          </a:prstGeom>
-          <a:noFill/>
-          <a:ln>
-            <a:noFill/>
-          </a:ln>
-        </p:spPr>
-        <p:txBody>
-          <a:bodyPr anchorCtr="0" anchor="t" bIns="0" lIns="0" spcFirstLastPara="1" rIns="0" wrap="square" tIns="0">
+            <a:off x="10424160" y="5669280"/>
+            <a:ext cx="1234440" cy="292607"/>
+          </a:xfrm>
+          <a:prstGeom prst="rect">
+            <a:avLst/>
+          </a:prstGeom>
+          <a:noFill/>
+          <a:ln>
+            <a:noFill/>
+          </a:ln>
+        </p:spPr>
+        <p:txBody>
+          <a:bodyPr anchorCtr="0" anchor="ctr" bIns="0" lIns="0" spcFirstLastPara="1" rIns="0" wrap="square" tIns="0">
             <a:spAutoFit/>
           </a:bodyPr>
           <a:lstStyle/>
           <a:p>
             <a:pPr indent="0" lvl="0" marL="0" marR="0" rtl="0" algn="l">
               <a:lnSpc>
-                <a:spcPct val="115000"/>
+                <a:spcPct val="105000"/>
               </a:lnSpc>
               <a:spcBef>
                 <a:spcPts val="0"/>
@@ -9008,152 +10673,65 @@
             <a:r>
               <a:rPr b="1" i="0" lang="en-US" sz="1200" u="none" cap="none" strike="noStrike">
                 <a:solidFill>
-                  <a:srgbClr val="6B7280"/>
-                </a:solidFill>
-                <a:latin typeface="Calibri"/>
-                <a:ea typeface="Calibri"/>
-                <a:cs typeface="Calibri"/>
-                <a:sym typeface="Calibri"/>
-              </a:rPr>
-              <a:t>HOW</a:t>
-            </a:r>
-            <a:endParaRPr b="1" sz="1500"/>
-          </a:p>
-        </p:txBody>
-      </p:sp>
-      <p:sp>
-        <p:nvSpPr>
-          <p:cNvPr id="458" name="Google Shape;458;g3dab19ec515_10_254"/>
-          <p:cNvSpPr txBox="1"/>
-          <p:nvPr/>
-        </p:nvSpPr>
-        <p:spPr>
-          <a:xfrm>
-            <a:off x="4560722" y="2377440"/>
-            <a:ext cx="3070200" cy="354000"/>
-          </a:xfrm>
-          <a:prstGeom prst="rect">
-            <a:avLst/>
-          </a:prstGeom>
-          <a:noFill/>
-          <a:ln>
-            <a:noFill/>
-          </a:ln>
-        </p:spPr>
-        <p:txBody>
-          <a:bodyPr anchorCtr="0" anchor="t" bIns="0" lIns="0" spcFirstLastPara="1" rIns="0" wrap="square" tIns="0">
-            <a:spAutoFit/>
-          </a:bodyPr>
-          <a:lstStyle/>
+                  <a:srgbClr val="FFFFFF"/>
+                </a:solidFill>
+                <a:latin typeface="Calibri"/>
+                <a:ea typeface="Calibri"/>
+                <a:cs typeface="Calibri"/>
+                <a:sym typeface="Calibri"/>
+              </a:rPr>
+              <a:t>Spanish</a:t>
+            </a:r>
+            <a:endParaRPr/>
+          </a:p>
           <a:p>
             <a:pPr indent="0" lvl="0" marL="0" marR="0" rtl="0" algn="l">
               <a:lnSpc>
-                <a:spcPct val="110000"/>
-              </a:lnSpc>
-              <a:spcBef>
-                <a:spcPts val="0"/>
-              </a:spcBef>
-              <a:spcAft>
-                <a:spcPts val="0"/>
-              </a:spcAft>
-              <a:buNone/>
-            </a:pPr>
-            <a:r>
-              <a:rPr b="1" i="0" lang="en-US" sz="2300" u="none" cap="none" strike="noStrike">
-                <a:solidFill>
-                  <a:srgbClr val="1A2A57"/>
-                </a:solidFill>
-                <a:latin typeface="Calibri"/>
-                <a:ea typeface="Calibri"/>
-                <a:cs typeface="Calibri"/>
-                <a:sym typeface="Calibri"/>
-              </a:rPr>
-              <a:t>Acoustic, not lexical</a:t>
-            </a:r>
-            <a:endParaRPr sz="1500"/>
-          </a:p>
-        </p:txBody>
-      </p:sp>
-      <p:sp>
-        <p:nvSpPr>
-          <p:cNvPr id="459" name="Google Shape;459;g3dab19ec515_10_254"/>
-          <p:cNvSpPr txBox="1"/>
-          <p:nvPr/>
-        </p:nvSpPr>
-        <p:spPr>
-          <a:xfrm>
-            <a:off x="4560747" y="2945188"/>
-            <a:ext cx="3070200" cy="1379100"/>
-          </a:xfrm>
-          <a:prstGeom prst="rect">
-            <a:avLst/>
-          </a:prstGeom>
-          <a:noFill/>
-          <a:ln>
-            <a:noFill/>
-          </a:ln>
-        </p:spPr>
-        <p:txBody>
-          <a:bodyPr anchorCtr="0" anchor="t" bIns="0" lIns="0" spcFirstLastPara="1" rIns="0" wrap="square" tIns="0">
-            <a:spAutoFit/>
-          </a:bodyPr>
-          <a:lstStyle/>
-          <a:p>
-            <a:pPr indent="0" lvl="0" marL="0" marR="0" rtl="0" algn="l">
-              <a:lnSpc>
-                <a:spcPct val="135000"/>
-              </a:lnSpc>
-              <a:spcBef>
-                <a:spcPts val="0"/>
-              </a:spcBef>
-              <a:spcAft>
-                <a:spcPts val="0"/>
-              </a:spcAft>
-              <a:buNone/>
-            </a:pPr>
-            <a:r>
-              <a:rPr b="1" i="0" lang="en-US" u="none" cap="none" strike="noStrike">
-                <a:solidFill>
-                  <a:srgbClr val="404755"/>
-                </a:solidFill>
-                <a:latin typeface="Calibri"/>
-                <a:ea typeface="Calibri"/>
-                <a:cs typeface="Calibri"/>
-                <a:sym typeface="Calibri"/>
-              </a:rPr>
-              <a:t>Four independent falsification tests agree: the layer-wise peak does not depend on words. Whisper alone resists the EMIS shortcut the only model with supervised multilingual pretraining.</a:t>
-            </a:r>
-            <a:endParaRPr b="1" sz="1500"/>
-          </a:p>
-        </p:txBody>
-      </p:sp>
-      <p:sp>
-        <p:nvSpPr>
-          <p:cNvPr id="460" name="Google Shape;460;g3dab19ec515_10_254"/>
+                <a:spcPct val="105000"/>
+              </a:lnSpc>
+              <a:spcBef>
+                <a:spcPts val="0"/>
+              </a:spcBef>
+              <a:spcAft>
+                <a:spcPts val="0"/>
+              </a:spcAft>
+              <a:buNone/>
+            </a:pPr>
+            <a:r>
+              <a:rPr b="0" i="0" lang="en-US" sz="1100" u="none" cap="none" strike="noStrike">
+                <a:solidFill>
+                  <a:srgbClr val="FFFFFF"/>
+                </a:solidFill>
+                <a:latin typeface="Calibri"/>
+                <a:ea typeface="Calibri"/>
+                <a:cs typeface="Calibri"/>
+                <a:sym typeface="Calibri"/>
+              </a:rPr>
+              <a:t>0.38 – 0.57</a:t>
+            </a:r>
+            <a:endParaRPr/>
+          </a:p>
+        </p:txBody>
+      </p:sp>
+      <p:sp>
+        <p:nvSpPr>
+          <p:cNvPr id="475" name="Google Shape;475;g3dad1aee3c2_3_0"/>
           <p:cNvSpPr/>
           <p:nvPr/>
         </p:nvSpPr>
         <p:spPr>
           <a:xfrm>
-            <a:off x="8069884" y="1783080"/>
-            <a:ext cx="3618900" cy="2834700"/>
-          </a:xfrm>
-          <a:prstGeom prst="roundRect">
-            <a:avLst>
-              <a:gd fmla="val 4000" name="adj"/>
-            </a:avLst>
+            <a:off x="457200" y="6126474"/>
+            <a:ext cx="11247000" cy="731400"/>
+          </a:xfrm>
+          <a:prstGeom prst="rect">
+            <a:avLst/>
           </a:prstGeom>
           <a:solidFill>
-            <a:srgbClr val="FFFFFF"/>
+            <a:srgbClr val="1E2761"/>
           </a:solidFill>
-          <a:ln cap="flat" cmpd="sng" w="12700">
-            <a:solidFill>
-              <a:srgbClr val="D5DBE8"/>
-            </a:solidFill>
-            <a:prstDash val="solid"/>
-            <a:round/>
-            <a:headEnd len="sm" w="sm" type="none"/>
-            <a:tailEnd len="sm" w="sm" type="none"/>
+          <a:ln>
+            <a:noFill/>
           </a:ln>
         </p:spPr>
         <p:txBody>
@@ -9191,32 +10769,30 @@
       </p:sp>
       <p:sp>
         <p:nvSpPr>
-          <p:cNvPr id="461" name="Google Shape;461;g3dab19ec515_10_254"/>
-          <p:cNvSpPr/>
-          <p:nvPr/>
-        </p:nvSpPr>
-        <p:spPr>
-          <a:xfrm>
-            <a:off x="8069884" y="1783080"/>
-            <a:ext cx="3618900" cy="91500"/>
-          </a:xfrm>
-          <a:prstGeom prst="rect">
-            <a:avLst/>
-          </a:prstGeom>
-          <a:solidFill>
-            <a:srgbClr val="2E8B57"/>
-          </a:solidFill>
-          <a:ln>
-            <a:noFill/>
-          </a:ln>
-        </p:spPr>
-        <p:txBody>
-          <a:bodyPr anchorCtr="0" anchor="ctr" bIns="45700" lIns="91425" spcFirstLastPara="1" rIns="91425" wrap="square" tIns="45700">
-            <a:noAutofit/>
-          </a:bodyPr>
-          <a:lstStyle/>
-          <a:p>
-            <a:pPr indent="0" lvl="0" marL="0" marR="0" rtl="0" algn="ctr">
+          <p:cNvPr id="476" name="Google Shape;476;g3dad1aee3c2_3_0"/>
+          <p:cNvSpPr txBox="1"/>
+          <p:nvPr/>
+        </p:nvSpPr>
+        <p:spPr>
+          <a:xfrm>
+            <a:off x="808650" y="6249850"/>
+            <a:ext cx="10605900" cy="461700"/>
+          </a:xfrm>
+          <a:prstGeom prst="rect">
+            <a:avLst/>
+          </a:prstGeom>
+          <a:noFill/>
+          <a:ln>
+            <a:noFill/>
+          </a:ln>
+        </p:spPr>
+        <p:txBody>
+          <a:bodyPr anchorCtr="0" anchor="ctr" bIns="0" lIns="0" spcFirstLastPara="1" rIns="0" wrap="square" tIns="0">
+            <a:spAutoFit/>
+          </a:bodyPr>
+          <a:lstStyle/>
+          <a:p>
+            <a:pPr indent="0" lvl="0" marL="0" marR="0" rtl="0" algn="l">
               <a:lnSpc>
                 <a:spcPct val="100000"/>
               </a:lnSpc>
@@ -9229,379 +10805,31 @@
               <a:buNone/>
             </a:pPr>
             <a:r>
-              <a:t/>
-            </a:r>
-            <a:endParaRPr b="0" i="0" sz="1400" u="none" cap="none" strike="noStrike">
-              <a:solidFill>
-                <a:srgbClr val="000000"/>
-              </a:solidFill>
-              <a:latin typeface="Arial"/>
-              <a:ea typeface="Arial"/>
-              <a:cs typeface="Arial"/>
-              <a:sym typeface="Arial"/>
-            </a:endParaRPr>
-          </a:p>
-        </p:txBody>
-      </p:sp>
-      <p:sp>
-        <p:nvSpPr>
-          <p:cNvPr id="462" name="Google Shape;462;g3dab19ec515_10_254"/>
-          <p:cNvSpPr txBox="1"/>
-          <p:nvPr/>
-        </p:nvSpPr>
-        <p:spPr>
-          <a:xfrm>
-            <a:off x="8344204" y="2057400"/>
-            <a:ext cx="3070200" cy="184800"/>
-          </a:xfrm>
-          <a:prstGeom prst="rect">
-            <a:avLst/>
-          </a:prstGeom>
-          <a:noFill/>
-          <a:ln>
-            <a:noFill/>
-          </a:ln>
-        </p:spPr>
-        <p:txBody>
-          <a:bodyPr anchorCtr="0" anchor="t" bIns="0" lIns="0" spcFirstLastPara="1" rIns="0" wrap="square" tIns="0">
-            <a:spAutoFit/>
-          </a:bodyPr>
-          <a:lstStyle/>
-          <a:p>
-            <a:pPr indent="0" lvl="0" marL="0" marR="0" rtl="0" algn="l">
-              <a:lnSpc>
-                <a:spcPct val="115000"/>
-              </a:lnSpc>
-              <a:spcBef>
-                <a:spcPts val="0"/>
-              </a:spcBef>
-              <a:spcAft>
-                <a:spcPts val="0"/>
-              </a:spcAft>
-              <a:buNone/>
-            </a:pPr>
-            <a:r>
-              <a:rPr b="1" i="0" lang="en-US" sz="1200" u="none" cap="none" strike="noStrike">
-                <a:solidFill>
-                  <a:srgbClr val="6B7280"/>
-                </a:solidFill>
-                <a:latin typeface="Calibri"/>
-                <a:ea typeface="Calibri"/>
-                <a:cs typeface="Calibri"/>
-                <a:sym typeface="Calibri"/>
-              </a:rPr>
-              <a:t>WHAT NEXT</a:t>
-            </a:r>
-            <a:endParaRPr b="1" sz="1500"/>
-          </a:p>
-        </p:txBody>
-      </p:sp>
-      <p:sp>
-        <p:nvSpPr>
-          <p:cNvPr id="463" name="Google Shape;463;g3dab19ec515_10_254"/>
-          <p:cNvSpPr txBox="1"/>
-          <p:nvPr/>
-        </p:nvSpPr>
-        <p:spPr>
-          <a:xfrm>
-            <a:off x="8344204" y="2377440"/>
-            <a:ext cx="3070200" cy="354000"/>
-          </a:xfrm>
-          <a:prstGeom prst="rect">
-            <a:avLst/>
-          </a:prstGeom>
-          <a:noFill/>
-          <a:ln>
-            <a:noFill/>
-          </a:ln>
-        </p:spPr>
-        <p:txBody>
-          <a:bodyPr anchorCtr="0" anchor="t" bIns="0" lIns="0" spcFirstLastPara="1" rIns="0" wrap="square" tIns="0">
-            <a:spAutoFit/>
-          </a:bodyPr>
-          <a:lstStyle/>
-          <a:p>
-            <a:pPr indent="0" lvl="0" marL="0" marR="0" rtl="0" algn="l">
-              <a:lnSpc>
-                <a:spcPct val="110000"/>
-              </a:lnSpc>
-              <a:spcBef>
-                <a:spcPts val="0"/>
-              </a:spcBef>
-              <a:spcAft>
-                <a:spcPts val="0"/>
-              </a:spcAft>
-              <a:buNone/>
-            </a:pPr>
-            <a:r>
-              <a:rPr b="1" i="0" lang="en-US" sz="2300" u="none" cap="none" strike="noStrike">
-                <a:solidFill>
-                  <a:srgbClr val="1A2A57"/>
-                </a:solidFill>
-                <a:latin typeface="Calibri"/>
-                <a:ea typeface="Calibri"/>
-                <a:cs typeface="Calibri"/>
-                <a:sym typeface="Calibri"/>
-              </a:rPr>
-              <a:t>Frozen is enough</a:t>
-            </a:r>
-            <a:endParaRPr sz="1500"/>
-          </a:p>
-        </p:txBody>
-      </p:sp>
-      <p:sp>
-        <p:nvSpPr>
-          <p:cNvPr id="464" name="Google Shape;464;g3dab19ec515_10_254"/>
-          <p:cNvSpPr txBox="1"/>
-          <p:nvPr/>
-        </p:nvSpPr>
-        <p:spPr>
-          <a:xfrm>
-            <a:off x="8344229" y="2945188"/>
-            <a:ext cx="3070200" cy="1379100"/>
-          </a:xfrm>
-          <a:prstGeom prst="rect">
-            <a:avLst/>
-          </a:prstGeom>
-          <a:noFill/>
-          <a:ln>
-            <a:noFill/>
-          </a:ln>
-        </p:spPr>
-        <p:txBody>
-          <a:bodyPr anchorCtr="0" anchor="t" bIns="0" lIns="0" spcFirstLastPara="1" rIns="0" wrap="square" tIns="0">
-            <a:spAutoFit/>
-          </a:bodyPr>
-          <a:lstStyle/>
-          <a:p>
-            <a:pPr indent="0" lvl="0" marL="0" marR="0" rtl="0" algn="l">
-              <a:lnSpc>
-                <a:spcPct val="135000"/>
-              </a:lnSpc>
-              <a:spcBef>
-                <a:spcPts val="0"/>
-              </a:spcBef>
-              <a:spcAft>
-                <a:spcPts val="0"/>
-              </a:spcAft>
-              <a:buNone/>
-            </a:pPr>
-            <a:r>
-              <a:rPr b="1" i="0" lang="en-US" u="none" cap="none" strike="noStrike">
-                <a:solidFill>
-                  <a:srgbClr val="404755"/>
-                </a:solidFill>
-                <a:latin typeface="Calibri"/>
-                <a:ea typeface="Calibri"/>
-                <a:cs typeface="Calibri"/>
-                <a:sym typeface="Calibri"/>
-              </a:rPr>
-              <a:t>LoRA hurts on 29/30 combos. The features already exist; no tuning is needed. Future work: extend SpeechCraft to 8-class emotion, validate on real-world deployment audio.</a:t>
-            </a:r>
-            <a:endParaRPr b="1" sz="1500"/>
-          </a:p>
-        </p:txBody>
-      </p:sp>
-      <p:sp>
-        <p:nvSpPr>
-          <p:cNvPr id="465" name="Google Shape;465;g3dab19ec515_10_254"/>
-          <p:cNvSpPr/>
-          <p:nvPr/>
-        </p:nvSpPr>
-        <p:spPr>
-          <a:xfrm>
-            <a:off x="0" y="5166600"/>
-            <a:ext cx="12191700" cy="1691400"/>
-          </a:xfrm>
-          <a:prstGeom prst="rect">
-            <a:avLst/>
-          </a:prstGeom>
-          <a:solidFill>
-            <a:srgbClr val="142147"/>
-          </a:solidFill>
-          <a:ln>
-            <a:noFill/>
-          </a:ln>
-        </p:spPr>
-        <p:txBody>
-          <a:bodyPr anchorCtr="0" anchor="ctr" bIns="45700" lIns="91425" spcFirstLastPara="1" rIns="91425" wrap="square" tIns="45700">
-            <a:noAutofit/>
-          </a:bodyPr>
-          <a:lstStyle/>
-          <a:p>
-            <a:pPr indent="0" lvl="0" marL="0" marR="0" rtl="0" algn="ctr">
-              <a:lnSpc>
-                <a:spcPct val="100000"/>
-              </a:lnSpc>
-              <a:spcBef>
-                <a:spcPts val="0"/>
-              </a:spcBef>
-              <a:spcAft>
-                <a:spcPts val="0"/>
-              </a:spcAft>
-              <a:buNone/>
-            </a:pPr>
-            <a:r>
-              <a:t/>
-            </a:r>
-            <a:endParaRPr b="0" i="0" sz="1400" u="none" cap="none" strike="noStrike">
-              <a:solidFill>
-                <a:srgbClr val="000000"/>
-              </a:solidFill>
-              <a:latin typeface="Arial"/>
-              <a:ea typeface="Arial"/>
-              <a:cs typeface="Arial"/>
-              <a:sym typeface="Arial"/>
-            </a:endParaRPr>
-          </a:p>
-        </p:txBody>
-      </p:sp>
-      <p:sp>
-        <p:nvSpPr>
-          <p:cNvPr id="466" name="Google Shape;466;g3dab19ec515_10_254"/>
-          <p:cNvSpPr/>
-          <p:nvPr/>
-        </p:nvSpPr>
-        <p:spPr>
-          <a:xfrm flipH="1" rot="10800000">
-            <a:off x="0" y="5166606"/>
-            <a:ext cx="12191700" cy="144300"/>
-          </a:xfrm>
-          <a:prstGeom prst="rect">
-            <a:avLst/>
-          </a:prstGeom>
-          <a:solidFill>
-            <a:srgbClr val="E8924A"/>
-          </a:solidFill>
-          <a:ln>
-            <a:noFill/>
-          </a:ln>
-        </p:spPr>
-        <p:txBody>
-          <a:bodyPr anchorCtr="0" anchor="ctr" bIns="45700" lIns="91425" spcFirstLastPara="1" rIns="91425" wrap="square" tIns="45700">
-            <a:noAutofit/>
-          </a:bodyPr>
-          <a:lstStyle/>
-          <a:p>
-            <a:pPr indent="0" lvl="0" marL="0" marR="0" rtl="0" algn="ctr">
-              <a:lnSpc>
-                <a:spcPct val="100000"/>
-              </a:lnSpc>
-              <a:spcBef>
-                <a:spcPts val="0"/>
-              </a:spcBef>
-              <a:spcAft>
-                <a:spcPts val="0"/>
-              </a:spcAft>
-              <a:buNone/>
-            </a:pPr>
-            <a:r>
-              <a:t/>
-            </a:r>
-            <a:endParaRPr b="0" i="0" sz="1400" u="none" cap="none" strike="noStrike">
-              <a:solidFill>
-                <a:srgbClr val="000000"/>
-              </a:solidFill>
-              <a:latin typeface="Arial"/>
-              <a:ea typeface="Arial"/>
-              <a:cs typeface="Arial"/>
-              <a:sym typeface="Arial"/>
-            </a:endParaRPr>
-          </a:p>
-        </p:txBody>
-      </p:sp>
-      <p:sp>
-        <p:nvSpPr>
-          <p:cNvPr id="467" name="Google Shape;467;g3dab19ec515_10_254"/>
-          <p:cNvSpPr txBox="1"/>
-          <p:nvPr/>
-        </p:nvSpPr>
-        <p:spPr>
-          <a:xfrm>
-            <a:off x="502920" y="5394985"/>
-            <a:ext cx="11338500" cy="292500"/>
-          </a:xfrm>
-          <a:prstGeom prst="rect">
-            <a:avLst/>
-          </a:prstGeom>
-          <a:noFill/>
-          <a:ln>
-            <a:noFill/>
-          </a:ln>
-        </p:spPr>
-        <p:txBody>
-          <a:bodyPr anchorCtr="0" anchor="t" bIns="0" lIns="0" spcFirstLastPara="1" rIns="0" wrap="square" tIns="0">
-            <a:spAutoFit/>
-          </a:bodyPr>
-          <a:lstStyle/>
-          <a:p>
-            <a:pPr indent="0" lvl="0" marL="0" marR="0" rtl="0" algn="l">
-              <a:lnSpc>
-                <a:spcPct val="100000"/>
-              </a:lnSpc>
-              <a:spcBef>
-                <a:spcPts val="0"/>
-              </a:spcBef>
-              <a:spcAft>
-                <a:spcPts val="0"/>
-              </a:spcAft>
-              <a:buNone/>
-            </a:pPr>
-            <a:r>
-              <a:rPr b="1" i="0" lang="en-US" sz="1900" u="none" cap="none" strike="noStrike">
-                <a:solidFill>
-                  <a:srgbClr val="E8924A"/>
-                </a:solidFill>
-                <a:latin typeface="Calibri"/>
-                <a:ea typeface="Calibri"/>
-                <a:cs typeface="Calibri"/>
-                <a:sym typeface="Calibri"/>
-              </a:rPr>
-              <a:t>The bottom line</a:t>
-            </a:r>
-            <a:endParaRPr sz="1900"/>
-          </a:p>
-        </p:txBody>
-      </p:sp>
-      <p:sp>
-        <p:nvSpPr>
-          <p:cNvPr id="468" name="Google Shape;468;g3dab19ec515_10_254"/>
-          <p:cNvSpPr txBox="1"/>
-          <p:nvPr/>
-        </p:nvSpPr>
-        <p:spPr>
-          <a:xfrm>
-            <a:off x="502920" y="5794920"/>
-            <a:ext cx="11338500" cy="672600"/>
-          </a:xfrm>
-          <a:prstGeom prst="rect">
-            <a:avLst/>
-          </a:prstGeom>
-          <a:noFill/>
-          <a:ln>
-            <a:noFill/>
-          </a:ln>
-        </p:spPr>
-        <p:txBody>
-          <a:bodyPr anchorCtr="0" anchor="t" bIns="0" lIns="0" spcFirstLastPara="1" rIns="0" wrap="square" tIns="0">
-            <a:spAutoFit/>
-          </a:bodyPr>
-          <a:lstStyle/>
-          <a:p>
-            <a:pPr indent="0" lvl="0" marL="0" marR="0" rtl="0" algn="l">
-              <a:lnSpc>
-                <a:spcPct val="130000"/>
-              </a:lnSpc>
-              <a:spcBef>
-                <a:spcPts val="0"/>
-              </a:spcBef>
-              <a:spcAft>
-                <a:spcPts val="0"/>
-              </a:spcAft>
-              <a:buNone/>
-            </a:pPr>
-            <a:r>
-              <a:rPr i="0" lang="en-US" sz="1900" u="none" cap="none" strike="noStrike">
+              <a:rPr b="1" i="0" lang="en-US" sz="1500" u="none" cap="none" strike="noStrike">
+                <a:solidFill>
+                  <a:srgbClr val="F4A261"/>
+                </a:solidFill>
+                <a:latin typeface="Calibri"/>
+                <a:ea typeface="Calibri"/>
+                <a:cs typeface="Calibri"/>
+                <a:sym typeface="Calibri"/>
+              </a:rPr>
+              <a:t>New finding:  </a:t>
+            </a:r>
+            <a:r>
+              <a:rPr b="0" i="0" lang="en-US" sz="1500" u="none" cap="none" strike="noStrike">
+                <a:solidFill>
+                  <a:srgbClr val="CADCFC"/>
+                </a:solidFill>
+                <a:latin typeface="Calibri"/>
+                <a:ea typeface="Calibri"/>
+                <a:cs typeface="Calibri"/>
+                <a:sym typeface="Calibri"/>
+              </a:rPr>
+              <a:t>pooled probes near-saturate at </a:t>
+            </a:r>
+            <a:r>
+              <a:rPr b="1" i="0" lang="en-US" sz="1500" u="none" cap="none" strike="noStrike">
                 <a:solidFill>
                   <a:srgbClr val="FFFFFF"/>
                 </a:solidFill>
@@ -9610,10 +10838,22 @@
                 <a:cs typeface="Calibri"/>
                 <a:sym typeface="Calibri"/>
               </a:rPr>
-              <a:t>Speech-emotion transformers </a:t>
-            </a:r>
-            <a:r>
-              <a:rPr i="1" lang="en-US" sz="1900" u="none" cap="none" strike="noStrike">
+              <a:t>0.93</a:t>
+            </a:r>
+            <a:r>
+              <a:rPr b="0" i="0" lang="en-US" sz="1500" u="none" cap="none" strike="noStrike">
+                <a:solidFill>
+                  <a:srgbClr val="CADCFC"/>
+                </a:solidFill>
+                <a:latin typeface="Calibri"/>
+                <a:ea typeface="Calibri"/>
+                <a:cs typeface="Calibri"/>
+                <a:sym typeface="Calibri"/>
+              </a:rPr>
+              <a:t>, but transfer is asymmetric — typologically nearby (</a:t>
+            </a:r>
+            <a:r>
+              <a:rPr b="1" i="0" lang="en-US" sz="1500" u="none" cap="none" strike="noStrike">
                 <a:solidFill>
                   <a:srgbClr val="FFFFFF"/>
                 </a:solidFill>
@@ -9622,10 +10862,22 @@
                 <a:cs typeface="Calibri"/>
                 <a:sym typeface="Calibri"/>
               </a:rPr>
-              <a:t>can </a:t>
-            </a:r>
-            <a:r>
-              <a:rPr i="0" lang="en-US" sz="1900" u="none" cap="none" strike="noStrike">
+              <a:t>German</a:t>
+            </a:r>
+            <a:r>
+              <a:rPr b="0" i="0" lang="en-US" sz="1500" u="none" cap="none" strike="noStrike">
+                <a:solidFill>
+                  <a:srgbClr val="CADCFC"/>
+                </a:solidFill>
+                <a:latin typeface="Calibri"/>
+                <a:ea typeface="Calibri"/>
+                <a:cs typeface="Calibri"/>
+                <a:sym typeface="Calibri"/>
+              </a:rPr>
+              <a:t>) generalises; </a:t>
+            </a:r>
+            <a:r>
+              <a:rPr b="1" i="0" lang="en-US" sz="1500" u="none" cap="none" strike="noStrike">
                 <a:solidFill>
                   <a:srgbClr val="FFFFFF"/>
                 </a:solidFill>
@@ -9634,31 +10886,19 @@
                 <a:cs typeface="Calibri"/>
                 <a:sym typeface="Calibri"/>
               </a:rPr>
-              <a:t>hear emotion in voice alone, but they do not always </a:t>
-            </a:r>
-            <a:r>
-              <a:rPr i="1" lang="en-US" sz="1900" u="none" cap="none" strike="noStrike">
-                <a:solidFill>
-                  <a:srgbClr val="FFFFFF"/>
-                </a:solidFill>
-                <a:latin typeface="Calibri"/>
-                <a:ea typeface="Calibri"/>
-                <a:cs typeface="Calibri"/>
-                <a:sym typeface="Calibri"/>
-              </a:rPr>
-              <a:t>choose </a:t>
-            </a:r>
-            <a:r>
-              <a:rPr i="0" lang="en-US" sz="1900" u="none" cap="none" strike="noStrike">
-                <a:solidFill>
-                  <a:srgbClr val="FFFFFF"/>
-                </a:solidFill>
-                <a:latin typeface="Calibri"/>
-                <a:ea typeface="Calibri"/>
-                <a:cs typeface="Calibri"/>
-                <a:sym typeface="Calibri"/>
-              </a:rPr>
-              <a:t>to. With the right probing recipe, you can locate exactly where the acoustic signal lives - and prove it is acoustic.</a:t>
+              <a:t>Spanish</a:t>
+            </a:r>
+            <a:r>
+              <a:rPr b="0" i="0" lang="en-US" sz="1500" u="none" cap="none" strike="noStrike">
+                <a:solidFill>
+                  <a:srgbClr val="CADCFC"/>
+                </a:solidFill>
+                <a:latin typeface="Calibri"/>
+                <a:ea typeface="Calibri"/>
+                <a:cs typeface="Calibri"/>
+                <a:sym typeface="Calibri"/>
+              </a:rPr>
+              <a:t> breaks (−0.55). The acoustic signal is real, not universal.</a:t>
             </a:r>
             <a:endParaRPr/>
           </a:p>
@@ -9677,7 +10917,7 @@
   <p:cSld>
     <p:spTree>
       <p:nvGrpSpPr>
-        <p:cNvPr id="473" name="Shape 473"/>
+        <p:cNvPr id="481" name="Shape 481"/>
         <p:cNvGrpSpPr/>
         <p:nvPr/>
       </p:nvGrpSpPr>
@@ -9691,7 +10931,7 @@
       </p:grpSpPr>
       <p:sp>
         <p:nvSpPr>
-          <p:cNvPr id="474" name="Google Shape;474;g3dab19ec515_5_64"/>
+          <p:cNvPr id="482" name="Google Shape;482;g3dab19ec515_5_64"/>
           <p:cNvSpPr/>
           <p:nvPr/>
         </p:nvSpPr>
@@ -9750,7 +10990,7 @@
       </p:sp>
       <p:sp>
         <p:nvSpPr>
-          <p:cNvPr id="475" name="Google Shape;475;g3dab19ec515_5_64"/>
+          <p:cNvPr id="483" name="Google Shape;483;g3dab19ec515_5_64"/>
           <p:cNvSpPr/>
           <p:nvPr/>
         </p:nvSpPr>
@@ -9809,7 +11049,7 @@
       </p:sp>
       <p:sp>
         <p:nvSpPr>
-          <p:cNvPr id="476" name="Google Shape;476;g3dab19ec515_5_64"/>
+          <p:cNvPr id="484" name="Google Shape;484;g3dab19ec515_5_64"/>
           <p:cNvSpPr txBox="1"/>
           <p:nvPr/>
         </p:nvSpPr>
@@ -9875,7 +11115,7 @@
       </p:sp>
       <p:sp>
         <p:nvSpPr>
-          <p:cNvPr id="477" name="Google Shape;477;g3dab19ec515_5_64"/>
+          <p:cNvPr id="485" name="Google Shape;485;g3dab19ec515_5_64"/>
           <p:cNvSpPr txBox="1"/>
           <p:nvPr/>
         </p:nvSpPr>
@@ -9941,7 +11181,7 @@
       </p:sp>
       <p:sp>
         <p:nvSpPr>
-          <p:cNvPr id="478" name="Google Shape;478;g3dab19ec515_5_64"/>
+          <p:cNvPr id="486" name="Google Shape;486;g3dab19ec515_5_64"/>
           <p:cNvSpPr txBox="1"/>
           <p:nvPr/>
         </p:nvSpPr>
@@ -10007,7 +11247,7 @@
       </p:sp>
       <p:sp>
         <p:nvSpPr>
-          <p:cNvPr id="479" name="Google Shape;479;g3dab19ec515_5_64"/>
+          <p:cNvPr id="487" name="Google Shape;487;g3dab19ec515_5_64"/>
           <p:cNvSpPr/>
           <p:nvPr/>
         </p:nvSpPr>
@@ -10074,7 +11314,7 @@
       </p:sp>
       <p:sp>
         <p:nvSpPr>
-          <p:cNvPr id="480" name="Google Shape;480;g3dab19ec515_5_64"/>
+          <p:cNvPr id="488" name="Google Shape;488;g3dab19ec515_5_64"/>
           <p:cNvSpPr/>
           <p:nvPr/>
         </p:nvSpPr>
@@ -10133,7 +11373,7 @@
       </p:sp>
       <p:sp>
         <p:nvSpPr>
-          <p:cNvPr id="481" name="Google Shape;481;g3dab19ec515_5_64"/>
+          <p:cNvPr id="489" name="Google Shape;489;g3dab19ec515_5_64"/>
           <p:cNvSpPr txBox="1"/>
           <p:nvPr/>
         </p:nvSpPr>
@@ -10199,7 +11439,7 @@
       </p:sp>
       <p:sp>
         <p:nvSpPr>
-          <p:cNvPr id="482" name="Google Shape;482;g3dab19ec515_5_64"/>
+          <p:cNvPr id="490" name="Google Shape;490;g3dab19ec515_5_64"/>
           <p:cNvSpPr txBox="1"/>
           <p:nvPr/>
         </p:nvSpPr>
@@ -10265,7 +11505,7 @@
       </p:sp>
       <p:sp>
         <p:nvSpPr>
-          <p:cNvPr id="483" name="Google Shape;483;g3dab19ec515_5_64"/>
+          <p:cNvPr id="491" name="Google Shape;491;g3dab19ec515_5_64"/>
           <p:cNvSpPr txBox="1"/>
           <p:nvPr/>
         </p:nvSpPr>
@@ -10331,7 +11571,7 @@
       </p:sp>
       <p:sp>
         <p:nvSpPr>
-          <p:cNvPr id="484" name="Google Shape;484;g3dab19ec515_5_64"/>
+          <p:cNvPr id="492" name="Google Shape;492;g3dab19ec515_5_64"/>
           <p:cNvSpPr/>
           <p:nvPr/>
         </p:nvSpPr>
@@ -10398,7 +11638,7 @@
       </p:sp>
       <p:sp>
         <p:nvSpPr>
-          <p:cNvPr id="485" name="Google Shape;485;g3dab19ec515_5_64"/>
+          <p:cNvPr id="493" name="Google Shape;493;g3dab19ec515_5_64"/>
           <p:cNvSpPr/>
           <p:nvPr/>
         </p:nvSpPr>
@@ -10457,7 +11697,7 @@
       </p:sp>
       <p:sp>
         <p:nvSpPr>
-          <p:cNvPr id="486" name="Google Shape;486;g3dab19ec515_5_64"/>
+          <p:cNvPr id="494" name="Google Shape;494;g3dab19ec515_5_64"/>
           <p:cNvSpPr txBox="1"/>
           <p:nvPr/>
         </p:nvSpPr>
@@ -10523,7 +11763,7 @@
       </p:sp>
       <p:sp>
         <p:nvSpPr>
-          <p:cNvPr id="487" name="Google Shape;487;g3dab19ec515_5_64"/>
+          <p:cNvPr id="495" name="Google Shape;495;g3dab19ec515_5_64"/>
           <p:cNvSpPr txBox="1"/>
           <p:nvPr/>
         </p:nvSpPr>
@@ -10589,7 +11829,7 @@
       </p:sp>
       <p:sp>
         <p:nvSpPr>
-          <p:cNvPr id="488" name="Google Shape;488;g3dab19ec515_5_64"/>
+          <p:cNvPr id="496" name="Google Shape;496;g3dab19ec515_5_64"/>
           <p:cNvSpPr txBox="1"/>
           <p:nvPr/>
         </p:nvSpPr>
@@ -10655,7 +11895,7 @@
       </p:sp>
       <p:sp>
         <p:nvSpPr>
-          <p:cNvPr id="489" name="Google Shape;489;g3dab19ec515_5_64"/>
+          <p:cNvPr id="497" name="Google Shape;497;g3dab19ec515_5_64"/>
           <p:cNvSpPr/>
           <p:nvPr/>
         </p:nvSpPr>
@@ -10722,7 +11962,7 @@
       </p:sp>
       <p:sp>
         <p:nvSpPr>
-          <p:cNvPr id="490" name="Google Shape;490;g3dab19ec515_5_64"/>
+          <p:cNvPr id="498" name="Google Shape;498;g3dab19ec515_5_64"/>
           <p:cNvSpPr/>
           <p:nvPr/>
         </p:nvSpPr>
@@ -10781,7 +12021,7 @@
       </p:sp>
       <p:sp>
         <p:nvSpPr>
-          <p:cNvPr id="491" name="Google Shape;491;g3dab19ec515_5_64"/>
+          <p:cNvPr id="499" name="Google Shape;499;g3dab19ec515_5_64"/>
           <p:cNvSpPr txBox="1"/>
           <p:nvPr/>
         </p:nvSpPr>
@@ -10847,7 +12087,7 @@
       </p:sp>
       <p:sp>
         <p:nvSpPr>
-          <p:cNvPr id="492" name="Google Shape;492;g3dab19ec515_5_64"/>
+          <p:cNvPr id="500" name="Google Shape;500;g3dab19ec515_5_64"/>
           <p:cNvSpPr txBox="1"/>
           <p:nvPr/>
         </p:nvSpPr>
@@ -10913,7 +12153,7 @@
       </p:sp>
       <p:sp>
         <p:nvSpPr>
-          <p:cNvPr id="493" name="Google Shape;493;g3dab19ec515_5_64"/>
+          <p:cNvPr id="501" name="Google Shape;501;g3dab19ec515_5_64"/>
           <p:cNvSpPr txBox="1"/>
           <p:nvPr/>
         </p:nvSpPr>
@@ -10979,7 +12219,7 @@
       </p:sp>
       <p:sp>
         <p:nvSpPr>
-          <p:cNvPr id="494" name="Google Shape;494;g3dab19ec515_5_64"/>
+          <p:cNvPr id="502" name="Google Shape;502;g3dab19ec515_5_64"/>
           <p:cNvSpPr/>
           <p:nvPr/>
         </p:nvSpPr>
@@ -11038,7 +12278,7 @@
       </p:sp>
       <p:sp>
         <p:nvSpPr>
-          <p:cNvPr id="495" name="Google Shape;495;g3dab19ec515_5_64"/>
+          <p:cNvPr id="503" name="Google Shape;503;g3dab19ec515_5_64"/>
           <p:cNvSpPr/>
           <p:nvPr/>
         </p:nvSpPr>
@@ -11097,7 +12337,7 @@
       </p:sp>
       <p:sp>
         <p:nvSpPr>
-          <p:cNvPr id="496" name="Google Shape;496;g3dab19ec515_5_64"/>
+          <p:cNvPr id="504" name="Google Shape;504;g3dab19ec515_5_64"/>
           <p:cNvSpPr txBox="1"/>
           <p:nvPr/>
         </p:nvSpPr>
@@ -11163,7 +12403,7 @@
       </p:sp>
       <p:sp>
         <p:nvSpPr>
-          <p:cNvPr id="497" name="Google Shape;497;g3dab19ec515_5_64"/>
+          <p:cNvPr id="505" name="Google Shape;505;g3dab19ec515_5_64"/>
           <p:cNvSpPr txBox="1"/>
           <p:nvPr/>
         </p:nvSpPr>
@@ -11288,7 +12528,7 @@
   <p:cSld>
     <p:spTree>
       <p:nvGrpSpPr>
-        <p:cNvPr id="502" name="Shape 502"/>
+        <p:cNvPr id="510" name="Shape 510"/>
         <p:cNvGrpSpPr/>
         <p:nvPr/>
       </p:nvGrpSpPr>
@@ -11302,7 +12542,7 @@
       </p:grpSpPr>
       <p:sp>
         <p:nvSpPr>
-          <p:cNvPr id="503" name="Google Shape;503;g3dab19ec515_12_0"/>
+          <p:cNvPr id="511" name="Google Shape;511;g3dab19ec515_12_0"/>
           <p:cNvSpPr/>
           <p:nvPr/>
         </p:nvSpPr>
@@ -11361,7 +12601,7 @@
       </p:sp>
       <p:sp>
         <p:nvSpPr>
-          <p:cNvPr id="504" name="Google Shape;504;g3dab19ec515_12_0"/>
+          <p:cNvPr id="512" name="Google Shape;512;g3dab19ec515_12_0"/>
           <p:cNvSpPr/>
           <p:nvPr/>
         </p:nvSpPr>
@@ -11420,7 +12660,7 @@
       </p:sp>
       <p:sp>
         <p:nvSpPr>
-          <p:cNvPr id="505" name="Google Shape;505;g3dab19ec515_12_0"/>
+          <p:cNvPr id="513" name="Google Shape;513;g3dab19ec515_12_0"/>
           <p:cNvSpPr txBox="1"/>
           <p:nvPr/>
         </p:nvSpPr>
@@ -11486,7 +12726,7 @@
       </p:sp>
       <p:sp>
         <p:nvSpPr>
-          <p:cNvPr id="506" name="Google Shape;506;g3dab19ec515_12_0"/>
+          <p:cNvPr id="514" name="Google Shape;514;g3dab19ec515_12_0"/>
           <p:cNvSpPr txBox="1"/>
           <p:nvPr/>
         </p:nvSpPr>
@@ -11548,7 +12788,7 @@
       </p:sp>
       <p:sp>
         <p:nvSpPr>
-          <p:cNvPr id="507" name="Google Shape;507;g3dab19ec515_12_0"/>
+          <p:cNvPr id="515" name="Google Shape;515;g3dab19ec515_12_0"/>
           <p:cNvSpPr txBox="1"/>
           <p:nvPr/>
         </p:nvSpPr>
@@ -11610,7 +12850,7 @@
       </p:sp>
       <p:sp>
         <p:nvSpPr>
-          <p:cNvPr id="508" name="Google Shape;508;g3dab19ec515_12_0"/>
+          <p:cNvPr id="516" name="Google Shape;516;g3dab19ec515_12_0"/>
           <p:cNvSpPr txBox="1"/>
           <p:nvPr/>
         </p:nvSpPr>
@@ -11676,7 +12916,7 @@
       </p:sp>
       <p:sp>
         <p:nvSpPr>
-          <p:cNvPr id="509" name="Google Shape;509;g3dab19ec515_12_0"/>
+          <p:cNvPr id="517" name="Google Shape;517;g3dab19ec515_12_0"/>
           <p:cNvSpPr/>
           <p:nvPr/>
         </p:nvSpPr>
@@ -11743,7 +12983,7 @@
       </p:sp>
       <p:sp>
         <p:nvSpPr>
-          <p:cNvPr id="510" name="Google Shape;510;g3dab19ec515_12_0"/>
+          <p:cNvPr id="518" name="Google Shape;518;g3dab19ec515_12_0"/>
           <p:cNvSpPr/>
           <p:nvPr/>
         </p:nvSpPr>
@@ -11802,7 +13042,7 @@
       </p:sp>
       <p:sp>
         <p:nvSpPr>
-          <p:cNvPr id="511" name="Google Shape;511;g3dab19ec515_12_0"/>
+          <p:cNvPr id="519" name="Google Shape;519;g3dab19ec515_12_0"/>
           <p:cNvSpPr txBox="1"/>
           <p:nvPr/>
         </p:nvSpPr>
@@ -11868,7 +13108,7 @@
       </p:sp>
       <p:sp>
         <p:nvSpPr>
-          <p:cNvPr id="512" name="Google Shape;512;g3dab19ec515_12_0"/>
+          <p:cNvPr id="520" name="Google Shape;520;g3dab19ec515_12_0"/>
           <p:cNvSpPr txBox="1"/>
           <p:nvPr/>
         </p:nvSpPr>
@@ -11934,7 +13174,7 @@
       </p:sp>
       <p:sp>
         <p:nvSpPr>
-          <p:cNvPr id="513" name="Google Shape;513;g3dab19ec515_12_0"/>
+          <p:cNvPr id="521" name="Google Shape;521;g3dab19ec515_12_0"/>
           <p:cNvSpPr txBox="1"/>
           <p:nvPr/>
         </p:nvSpPr>
@@ -12000,14 +13240,14 @@
       </p:sp>
       <p:sp>
         <p:nvSpPr>
-          <p:cNvPr id="514" name="Google Shape;514;g3dab19ec515_12_0"/>
+          <p:cNvPr id="522" name="Google Shape;522;g3dab19ec515_12_0"/>
           <p:cNvSpPr/>
           <p:nvPr/>
         </p:nvSpPr>
         <p:spPr>
           <a:xfrm>
             <a:off x="502925" y="3218675"/>
-            <a:ext cx="4317300" cy="1012500"/>
+            <a:ext cx="4317300" cy="1079100"/>
           </a:xfrm>
           <a:prstGeom prst="roundRect">
             <a:avLst>
@@ -12067,7 +13307,7 @@
       </p:sp>
       <p:sp>
         <p:nvSpPr>
-          <p:cNvPr id="515" name="Google Shape;515;g3dab19ec515_12_0"/>
+          <p:cNvPr id="523" name="Google Shape;523;g3dab19ec515_12_0"/>
           <p:cNvSpPr/>
           <p:nvPr/>
         </p:nvSpPr>
@@ -12126,7 +13366,7 @@
       </p:sp>
       <p:sp>
         <p:nvSpPr>
-          <p:cNvPr id="516" name="Google Shape;516;g3dab19ec515_12_0"/>
+          <p:cNvPr id="524" name="Google Shape;524;g3dab19ec515_12_0"/>
           <p:cNvSpPr txBox="1"/>
           <p:nvPr/>
         </p:nvSpPr>
@@ -12192,7 +13432,7 @@
       </p:sp>
       <p:sp>
         <p:nvSpPr>
-          <p:cNvPr id="517" name="Google Shape;517;g3dab19ec515_12_0"/>
+          <p:cNvPr id="525" name="Google Shape;525;g3dab19ec515_12_0"/>
           <p:cNvSpPr txBox="1"/>
           <p:nvPr/>
         </p:nvSpPr>
@@ -12254,7 +13494,7 @@
       </p:sp>
       <p:sp>
         <p:nvSpPr>
-          <p:cNvPr id="518" name="Google Shape;518;g3dab19ec515_12_0"/>
+          <p:cNvPr id="526" name="Google Shape;526;g3dab19ec515_12_0"/>
           <p:cNvSpPr txBox="1"/>
           <p:nvPr/>
         </p:nvSpPr>
@@ -12320,14 +13560,14 @@
       </p:sp>
       <p:sp>
         <p:nvSpPr>
-          <p:cNvPr id="519" name="Google Shape;519;g3dab19ec515_12_0"/>
+          <p:cNvPr id="527" name="Google Shape;527;g3dab19ec515_12_0"/>
           <p:cNvSpPr/>
           <p:nvPr/>
         </p:nvSpPr>
         <p:spPr>
           <a:xfrm>
-            <a:off x="502925" y="4425700"/>
-            <a:ext cx="4317300" cy="939300"/>
+            <a:off x="502925" y="4352500"/>
+            <a:ext cx="4317300" cy="1079100"/>
           </a:xfrm>
           <a:prstGeom prst="roundRect">
             <a:avLst>
@@ -12387,14 +13627,14 @@
       </p:sp>
       <p:sp>
         <p:nvSpPr>
-          <p:cNvPr id="520" name="Google Shape;520;g3dab19ec515_12_0"/>
+          <p:cNvPr id="528" name="Google Shape;528;g3dab19ec515_12_0"/>
           <p:cNvSpPr/>
           <p:nvPr/>
         </p:nvSpPr>
         <p:spPr>
           <a:xfrm>
-            <a:off x="502920" y="4352544"/>
-            <a:ext cx="91440" cy="1078992"/>
+            <a:off x="502925" y="4352550"/>
+            <a:ext cx="91500" cy="1079100"/>
           </a:xfrm>
           <a:prstGeom prst="rect">
             <a:avLst/>
@@ -12446,7 +13686,7 @@
       </p:sp>
       <p:sp>
         <p:nvSpPr>
-          <p:cNvPr id="521" name="Google Shape;521;g3dab19ec515_12_0"/>
+          <p:cNvPr id="529" name="Google Shape;529;g3dab19ec515_12_0"/>
           <p:cNvSpPr txBox="1"/>
           <p:nvPr/>
         </p:nvSpPr>
@@ -12512,7 +13752,7 @@
       </p:sp>
       <p:sp>
         <p:nvSpPr>
-          <p:cNvPr id="522" name="Google Shape;522;g3dab19ec515_12_0"/>
+          <p:cNvPr id="530" name="Google Shape;530;g3dab19ec515_12_0"/>
           <p:cNvSpPr txBox="1"/>
           <p:nvPr/>
         </p:nvSpPr>
@@ -12578,7 +13818,7 @@
       </p:sp>
       <p:sp>
         <p:nvSpPr>
-          <p:cNvPr id="523" name="Google Shape;523;g3dab19ec515_12_0"/>
+          <p:cNvPr id="531" name="Google Shape;531;g3dab19ec515_12_0"/>
           <p:cNvSpPr txBox="1"/>
           <p:nvPr/>
         </p:nvSpPr>
@@ -12644,7 +13884,7 @@
       </p:sp>
       <p:sp>
         <p:nvSpPr>
-          <p:cNvPr id="524" name="Google Shape;524;g3dab19ec515_12_0"/>
+          <p:cNvPr id="532" name="Google Shape;532;g3dab19ec515_12_0"/>
           <p:cNvSpPr/>
           <p:nvPr/>
         </p:nvSpPr>
@@ -12711,7 +13951,7 @@
       </p:sp>
       <p:sp>
         <p:nvSpPr>
-          <p:cNvPr id="525" name="Google Shape;525;g3dab19ec515_12_0"/>
+          <p:cNvPr id="533" name="Google Shape;533;g3dab19ec515_12_0"/>
           <p:cNvSpPr/>
           <p:nvPr/>
         </p:nvSpPr>
@@ -12770,7 +14010,7 @@
       </p:sp>
       <p:sp>
         <p:nvSpPr>
-          <p:cNvPr id="526" name="Google Shape;526;g3dab19ec515_12_0"/>
+          <p:cNvPr id="534" name="Google Shape;534;g3dab19ec515_12_0"/>
           <p:cNvSpPr txBox="1"/>
           <p:nvPr/>
         </p:nvSpPr>
@@ -12836,7 +14076,7 @@
       </p:sp>
       <p:sp>
         <p:nvSpPr>
-          <p:cNvPr id="527" name="Google Shape;527;g3dab19ec515_12_0"/>
+          <p:cNvPr id="535" name="Google Shape;535;g3dab19ec515_12_0"/>
           <p:cNvSpPr txBox="1"/>
           <p:nvPr/>
         </p:nvSpPr>
@@ -12902,7 +14142,7 @@
       </p:sp>
       <p:sp>
         <p:nvSpPr>
-          <p:cNvPr id="528" name="Google Shape;528;g3dab19ec515_12_0"/>
+          <p:cNvPr id="536" name="Google Shape;536;g3dab19ec515_12_0"/>
           <p:cNvSpPr txBox="1"/>
           <p:nvPr/>
         </p:nvSpPr>
@@ -12968,7 +14208,7 @@
       </p:sp>
       <p:sp>
         <p:nvSpPr>
-          <p:cNvPr id="529" name="Google Shape;529;g3dab19ec515_12_0"/>
+          <p:cNvPr id="537" name="Google Shape;537;g3dab19ec515_12_0"/>
           <p:cNvSpPr txBox="1"/>
           <p:nvPr/>
         </p:nvSpPr>
@@ -13034,14 +14274,14 @@
       </p:sp>
       <p:sp>
         <p:nvSpPr>
-          <p:cNvPr id="530" name="Google Shape;530;g3dab19ec515_12_0"/>
+          <p:cNvPr id="538" name="Google Shape;538;g3dab19ec515_12_0"/>
           <p:cNvSpPr/>
           <p:nvPr/>
         </p:nvSpPr>
         <p:spPr>
           <a:xfrm>
             <a:off x="4960050" y="2093925"/>
-            <a:ext cx="6873900" cy="1079100"/>
+            <a:ext cx="6878100" cy="1079100"/>
           </a:xfrm>
           <a:prstGeom prst="roundRect">
             <a:avLst>
@@ -13101,7 +14341,7 @@
       </p:sp>
       <p:sp>
         <p:nvSpPr>
-          <p:cNvPr id="531" name="Google Shape;531;g3dab19ec515_12_0"/>
+          <p:cNvPr id="539" name="Google Shape;539;g3dab19ec515_12_0"/>
           <p:cNvSpPr/>
           <p:nvPr/>
         </p:nvSpPr>
@@ -13160,7 +14400,7 @@
       </p:sp>
       <p:sp>
         <p:nvSpPr>
-          <p:cNvPr id="532" name="Google Shape;532;g3dab19ec515_12_0"/>
+          <p:cNvPr id="540" name="Google Shape;540;g3dab19ec515_12_0"/>
           <p:cNvSpPr txBox="1"/>
           <p:nvPr/>
         </p:nvSpPr>
@@ -13226,13 +14466,13 @@
       </p:sp>
       <p:sp>
         <p:nvSpPr>
-          <p:cNvPr id="533" name="Google Shape;533;g3dab19ec515_12_0"/>
+          <p:cNvPr id="541" name="Google Shape;541;g3dab19ec515_12_0"/>
           <p:cNvSpPr txBox="1"/>
           <p:nvPr/>
         </p:nvSpPr>
         <p:spPr>
           <a:xfrm>
-            <a:off x="5191375" y="2435650"/>
+            <a:off x="5191375" y="2358850"/>
             <a:ext cx="6403200" cy="692700"/>
           </a:xfrm>
           <a:prstGeom prst="rect">
@@ -13249,7 +14489,7 @@
           </a:bodyPr>
           <a:lstStyle/>
           <a:p>
-            <a:pPr indent="0" lvl="0" marL="0" marR="0" rtl="0" algn="l">
+            <a:pPr indent="0" lvl="0" marL="0" marR="0" rtl="0" algn="just">
               <a:lnSpc>
                 <a:spcPct val="90000"/>
               </a:lnSpc>
@@ -13276,7 +14516,31 @@
                 <a:cs typeface="Calibri"/>
                 <a:sym typeface="Calibri"/>
               </a:rPr>
-              <a:t>Built a pipeline for running experiments using slurm command. Extended the probing grid to six encoders (added WavLM Base+, w2v-BERT, and MERT), built the ESC-50 noise-augmentation and MSP-Podcast spontaneous-speech pipelines. Led the V/A/D regression track - clean, noisy, and V/A/D-as-features for classification. Overally ran 360 experiments for fully test frozen layer setup.</a:t>
+              <a:t>Built a</a:t>
+            </a:r>
+            <a:r>
+              <a:rPr b="1" i="0" lang="en-US" sz="1250" u="none" cap="none" strike="noStrike">
+                <a:solidFill>
+                  <a:srgbClr val="404755"/>
+                </a:solidFill>
+                <a:latin typeface="Calibri"/>
+                <a:ea typeface="Calibri"/>
+                <a:cs typeface="Calibri"/>
+                <a:sym typeface="Calibri"/>
+              </a:rPr>
+              <a:t> </a:t>
+            </a:r>
+            <a:r>
+              <a:rPr b="1" i="0" lang="en-US" sz="1250" u="none" cap="none" strike="noStrike">
+                <a:solidFill>
+                  <a:srgbClr val="404755"/>
+                </a:solidFill>
+                <a:latin typeface="Calibri"/>
+                <a:ea typeface="Calibri"/>
+                <a:cs typeface="Calibri"/>
+                <a:sym typeface="Calibri"/>
+              </a:rPr>
+              <a:t>pipeline for running experiments using slurm command. Extended the probing grid to six encoders (added WavLM Base+, w2v-BERT, and MERT), built the ESC-50 noise-augmentation and MSP-Podcast spontaneous-speech pipelines. Led the V/A/D regression track - clean, noisy, and V/A/D-as-features for classification. Overally ran 360 experiments for fully test frozen layer setup.</a:t>
             </a:r>
             <a:endParaRPr b="1" i="0" sz="1700" u="none" cap="none" strike="noStrike">
               <a:solidFill>
@@ -13292,14 +14556,14 @@
       </p:sp>
       <p:sp>
         <p:nvSpPr>
-          <p:cNvPr id="534" name="Google Shape;534;g3dab19ec515_12_0"/>
+          <p:cNvPr id="542" name="Google Shape;542;g3dab19ec515_12_0"/>
           <p:cNvSpPr/>
           <p:nvPr/>
         </p:nvSpPr>
         <p:spPr>
           <a:xfrm>
-            <a:off x="4960059" y="3218675"/>
-            <a:ext cx="6771600" cy="1079100"/>
+            <a:off x="4960050" y="3218675"/>
+            <a:ext cx="6878100" cy="1079100"/>
           </a:xfrm>
           <a:prstGeom prst="roundRect">
             <a:avLst>
@@ -13359,7 +14623,7 @@
       </p:sp>
       <p:sp>
         <p:nvSpPr>
-          <p:cNvPr id="535" name="Google Shape;535;g3dab19ec515_12_0"/>
+          <p:cNvPr id="543" name="Google Shape;543;g3dab19ec515_12_0"/>
           <p:cNvSpPr/>
           <p:nvPr/>
         </p:nvSpPr>
@@ -13418,7 +14682,7 @@
       </p:sp>
       <p:sp>
         <p:nvSpPr>
-          <p:cNvPr id="536" name="Google Shape;536;g3dab19ec515_12_0"/>
+          <p:cNvPr id="544" name="Google Shape;544;g3dab19ec515_12_0"/>
           <p:cNvSpPr txBox="1"/>
           <p:nvPr/>
         </p:nvSpPr>
@@ -13484,7 +14748,7 @@
       </p:sp>
       <p:sp>
         <p:nvSpPr>
-          <p:cNvPr id="537" name="Google Shape;537;g3dab19ec515_12_0"/>
+          <p:cNvPr id="545" name="Google Shape;545;g3dab19ec515_12_0"/>
           <p:cNvSpPr txBox="1"/>
           <p:nvPr/>
         </p:nvSpPr>
@@ -13541,14 +14805,14 @@
       </p:sp>
       <p:sp>
         <p:nvSpPr>
-          <p:cNvPr id="538" name="Google Shape;538;g3dab19ec515_12_0"/>
+          <p:cNvPr id="546" name="Google Shape;546;g3dab19ec515_12_0"/>
           <p:cNvSpPr/>
           <p:nvPr/>
         </p:nvSpPr>
         <p:spPr>
           <a:xfrm>
             <a:off x="4960150" y="4352550"/>
-            <a:ext cx="6771600" cy="1258800"/>
+            <a:ext cx="6878100" cy="1079100"/>
           </a:xfrm>
           <a:prstGeom prst="roundRect">
             <a:avLst>
@@ -13608,7 +14872,7 @@
       </p:sp>
       <p:sp>
         <p:nvSpPr>
-          <p:cNvPr id="539" name="Google Shape;539;g3dab19ec515_12_0"/>
+          <p:cNvPr id="547" name="Google Shape;547;g3dab19ec515_12_0"/>
           <p:cNvSpPr/>
           <p:nvPr/>
         </p:nvSpPr>
@@ -13667,7 +14931,7 @@
       </p:sp>
       <p:sp>
         <p:nvSpPr>
-          <p:cNvPr id="540" name="Google Shape;540;g3dab19ec515_12_0"/>
+          <p:cNvPr id="548" name="Google Shape;548;g3dab19ec515_12_0"/>
           <p:cNvSpPr txBox="1"/>
           <p:nvPr/>
         </p:nvSpPr>
@@ -13733,14 +14997,14 @@
       </p:sp>
       <p:sp>
         <p:nvSpPr>
-          <p:cNvPr id="541" name="Google Shape;541;g3dab19ec515_12_0"/>
+          <p:cNvPr id="549" name="Google Shape;549;g3dab19ec515_12_0"/>
           <p:cNvSpPr txBox="1"/>
           <p:nvPr/>
         </p:nvSpPr>
         <p:spPr>
           <a:xfrm>
-            <a:off x="5191375" y="4649225"/>
-            <a:ext cx="6403200" cy="962100"/>
+            <a:off x="5161475" y="4663613"/>
+            <a:ext cx="6646800" cy="769500"/>
           </a:xfrm>
           <a:prstGeom prst="rect">
             <a:avLst/>
@@ -13783,7 +15047,7 @@
                 <a:cs typeface="Calibri"/>
                 <a:sym typeface="Calibri"/>
               </a:rPr>
-              <a:t>BERT alignment via CCA, CKA, Procrustes, and centroid transfer to measure how text like the speech features get at each layer. Built the layer mixer with softmax attention over 25 hidden states, showing Whisper concentrates 79-94 percent of attention on layer 24. Ran LoRA across 30 combos, proving features already exist in pretraining. Added CREMA D probing as the cleanest acoustic test.</a:t>
+              <a:t>BERT alignment via CCA, CKA, Procrustes, and centroid transfer to measure how text like the speechfeatures get at each layer. Built the layer mixer with softmax attention over 25 hidden states, showing Whisper concentrates 79-94 percent of attention on layer 24. Ran LoRA across 30 combos, proving features already exist in pretraining. Added CREMA D probing as the cleanest acoustic test.</a:t>
             </a:r>
             <a:endParaRPr b="1" i="0" sz="1250" u="none" cap="none" strike="noStrike">
               <a:solidFill>
@@ -13799,14 +15063,14 @@
       </p:sp>
       <p:sp>
         <p:nvSpPr>
-          <p:cNvPr id="542" name="Google Shape;542;g3dab19ec515_12_0"/>
+          <p:cNvPr id="550" name="Google Shape;550;g3dab19ec515_12_0"/>
           <p:cNvSpPr/>
           <p:nvPr/>
         </p:nvSpPr>
         <p:spPr>
           <a:xfrm>
-            <a:off x="4960050" y="5626200"/>
-            <a:ext cx="6771600" cy="939300"/>
+            <a:off x="4960050" y="5486500"/>
+            <a:ext cx="6771600" cy="1079100"/>
           </a:xfrm>
           <a:prstGeom prst="roundRect">
             <a:avLst>
@@ -13866,7 +15130,7 @@
       </p:sp>
       <p:sp>
         <p:nvSpPr>
-          <p:cNvPr id="543" name="Google Shape;543;g3dab19ec515_12_0"/>
+          <p:cNvPr id="551" name="Google Shape;551;g3dab19ec515_12_0"/>
           <p:cNvSpPr/>
           <p:nvPr/>
         </p:nvSpPr>
@@ -13925,13 +15189,13 @@
       </p:sp>
       <p:sp>
         <p:nvSpPr>
-          <p:cNvPr id="544" name="Google Shape;544;g3dab19ec515_12_0"/>
+          <p:cNvPr id="552" name="Google Shape;552;g3dab19ec515_12_0"/>
           <p:cNvSpPr txBox="1"/>
           <p:nvPr/>
         </p:nvSpPr>
         <p:spPr>
           <a:xfrm>
-            <a:off x="5191375" y="5675438"/>
+            <a:off x="5191375" y="5486413"/>
             <a:ext cx="4919400" cy="223200"/>
           </a:xfrm>
           <a:prstGeom prst="rect">
@@ -13991,13 +15255,13 @@
       </p:sp>
       <p:sp>
         <p:nvSpPr>
-          <p:cNvPr id="545" name="Google Shape;545;g3dab19ec515_12_0"/>
+          <p:cNvPr id="553" name="Google Shape;553;g3dab19ec515_12_0"/>
           <p:cNvSpPr txBox="1"/>
           <p:nvPr/>
         </p:nvSpPr>
         <p:spPr>
           <a:xfrm>
-            <a:off x="5191377" y="5962775"/>
+            <a:off x="5191377" y="5824375"/>
             <a:ext cx="6403200" cy="384900"/>
           </a:xfrm>
           <a:prstGeom prst="rect">
@@ -14041,7 +15305,7 @@
                 <a:cs typeface="Calibri"/>
                 <a:sym typeface="Calibri"/>
               </a:rPr>
-              <a:t>compiled Speechcraft benchmark across  models for multilingual pooled lingual generalization testing</a:t>
+              <a:t>compiled Speechcraft benchmark across  models for multilingual pooled lingual generalization testing and cross lingual stress tests</a:t>
             </a:r>
             <a:endParaRPr b="1" i="0" sz="1250" u="none" cap="none" strike="noStrike">
               <a:solidFill>
@@ -14068,7 +15332,7 @@
   <p:cSld>
     <p:spTree>
       <p:nvGrpSpPr>
-        <p:cNvPr id="550" name="Shape 550"/>
+        <p:cNvPr id="558" name="Shape 558"/>
         <p:cNvGrpSpPr/>
         <p:nvPr/>
       </p:nvGrpSpPr>
@@ -14082,7 +15346,7 @@
       </p:grpSpPr>
       <p:sp>
         <p:nvSpPr>
-          <p:cNvPr id="551" name="Google Shape;551;g3dab19ec515_10_282"/>
+          <p:cNvPr id="559" name="Google Shape;559;g3dab19ec515_10_282"/>
           <p:cNvSpPr/>
           <p:nvPr/>
         </p:nvSpPr>
@@ -14136,7 +15400,7 @@
       </p:sp>
       <p:sp>
         <p:nvSpPr>
-          <p:cNvPr id="552" name="Google Shape;552;g3dab19ec515_10_282"/>
+          <p:cNvPr id="560" name="Google Shape;560;g3dab19ec515_10_282"/>
           <p:cNvSpPr/>
           <p:nvPr/>
         </p:nvSpPr>
@@ -14190,7 +15454,7 @@
       </p:sp>
       <p:sp>
         <p:nvSpPr>
-          <p:cNvPr id="553" name="Google Shape;553;g3dab19ec515_10_282"/>
+          <p:cNvPr id="561" name="Google Shape;561;g3dab19ec515_10_282"/>
           <p:cNvSpPr txBox="1"/>
           <p:nvPr/>
         </p:nvSpPr>
@@ -14243,7 +15507,7 @@
       </p:sp>
       <p:sp>
         <p:nvSpPr>
-          <p:cNvPr id="554" name="Google Shape;554;g3dab19ec515_10_282"/>
+          <p:cNvPr id="562" name="Google Shape;562;g3dab19ec515_10_282"/>
           <p:cNvSpPr txBox="1"/>
           <p:nvPr/>
         </p:nvSpPr>
@@ -14296,7 +15560,7 @@
       </p:sp>
       <p:sp>
         <p:nvSpPr>
-          <p:cNvPr id="555" name="Google Shape;555;g3dab19ec515_10_282"/>
+          <p:cNvPr id="563" name="Google Shape;563;g3dab19ec515_10_282"/>
           <p:cNvSpPr txBox="1"/>
           <p:nvPr/>
         </p:nvSpPr>
@@ -14349,7 +15613,7 @@
       </p:sp>
       <p:sp>
         <p:nvSpPr>
-          <p:cNvPr id="556" name="Google Shape;556;g3dab19ec515_10_282"/>
+          <p:cNvPr id="564" name="Google Shape;564;g3dab19ec515_10_282"/>
           <p:cNvSpPr/>
           <p:nvPr/>
         </p:nvSpPr>
@@ -14403,7 +15667,7 @@
       </p:sp>
       <p:sp>
         <p:nvSpPr>
-          <p:cNvPr id="557" name="Google Shape;557;g3dab19ec515_10_282"/>
+          <p:cNvPr id="565" name="Google Shape;565;g3dab19ec515_10_282"/>
           <p:cNvSpPr txBox="1"/>
           <p:nvPr/>
         </p:nvSpPr>
@@ -14519,7 +15783,7 @@
       </p:sp>
       <p:sp>
         <p:nvSpPr>
-          <p:cNvPr id="558" name="Google Shape;558;g3dab19ec515_10_282"/>
+          <p:cNvPr id="566" name="Google Shape;566;g3dab19ec515_10_282"/>
           <p:cNvSpPr/>
           <p:nvPr/>
         </p:nvSpPr>
@@ -14573,7 +15837,7 @@
       </p:sp>
       <p:sp>
         <p:nvSpPr>
-          <p:cNvPr id="559" name="Google Shape;559;g3dab19ec515_10_282"/>
+          <p:cNvPr id="567" name="Google Shape;567;g3dab19ec515_10_282"/>
           <p:cNvSpPr txBox="1"/>
           <p:nvPr/>
         </p:nvSpPr>
@@ -14689,7 +15953,7 @@
       </p:sp>
       <p:sp>
         <p:nvSpPr>
-          <p:cNvPr id="560" name="Google Shape;560;g3dab19ec515_10_282"/>
+          <p:cNvPr id="568" name="Google Shape;568;g3dab19ec515_10_282"/>
           <p:cNvSpPr/>
           <p:nvPr/>
         </p:nvSpPr>
@@ -14743,7 +16007,7 @@
       </p:sp>
       <p:sp>
         <p:nvSpPr>
-          <p:cNvPr id="561" name="Google Shape;561;g3dab19ec515_10_282"/>
+          <p:cNvPr id="569" name="Google Shape;569;g3dab19ec515_10_282"/>
           <p:cNvSpPr txBox="1"/>
           <p:nvPr/>
         </p:nvSpPr>
@@ -14859,7 +16123,7 @@
       </p:sp>
       <p:sp>
         <p:nvSpPr>
-          <p:cNvPr id="562" name="Google Shape;562;g3dab19ec515_10_282"/>
+          <p:cNvPr id="570" name="Google Shape;570;g3dab19ec515_10_282"/>
           <p:cNvSpPr/>
           <p:nvPr/>
         </p:nvSpPr>
@@ -14913,7 +16177,7 @@
       </p:sp>
       <p:sp>
         <p:nvSpPr>
-          <p:cNvPr id="563" name="Google Shape;563;g3dab19ec515_10_282"/>
+          <p:cNvPr id="571" name="Google Shape;571;g3dab19ec515_10_282"/>
           <p:cNvSpPr txBox="1"/>
           <p:nvPr/>
         </p:nvSpPr>
@@ -15029,7 +16293,7 @@
       </p:sp>
       <p:sp>
         <p:nvSpPr>
-          <p:cNvPr id="564" name="Google Shape;564;g3dab19ec515_10_282"/>
+          <p:cNvPr id="572" name="Google Shape;572;g3dab19ec515_10_282"/>
           <p:cNvSpPr/>
           <p:nvPr/>
         </p:nvSpPr>
@@ -15083,7 +16347,7 @@
       </p:sp>
       <p:sp>
         <p:nvSpPr>
-          <p:cNvPr id="565" name="Google Shape;565;g3dab19ec515_10_282"/>
+          <p:cNvPr id="573" name="Google Shape;573;g3dab19ec515_10_282"/>
           <p:cNvSpPr txBox="1"/>
           <p:nvPr/>
         </p:nvSpPr>
@@ -15199,7 +16463,7 @@
       </p:sp>
       <p:sp>
         <p:nvSpPr>
-          <p:cNvPr id="566" name="Google Shape;566;g3dab19ec515_10_282"/>
+          <p:cNvPr id="574" name="Google Shape;574;g3dab19ec515_10_282"/>
           <p:cNvSpPr/>
           <p:nvPr/>
         </p:nvSpPr>
@@ -15253,7 +16517,7 @@
       </p:sp>
       <p:sp>
         <p:nvSpPr>
-          <p:cNvPr id="567" name="Google Shape;567;g3dab19ec515_10_282"/>
+          <p:cNvPr id="575" name="Google Shape;575;g3dab19ec515_10_282"/>
           <p:cNvSpPr txBox="1"/>
           <p:nvPr/>
         </p:nvSpPr>
@@ -15369,7 +16633,7 @@
       </p:sp>
       <p:sp>
         <p:nvSpPr>
-          <p:cNvPr id="568" name="Google Shape;568;g3dab19ec515_10_282"/>
+          <p:cNvPr id="576" name="Google Shape;576;g3dab19ec515_10_282"/>
           <p:cNvSpPr/>
           <p:nvPr/>
         </p:nvSpPr>
@@ -15423,7 +16687,7 @@
       </p:sp>
       <p:sp>
         <p:nvSpPr>
-          <p:cNvPr id="569" name="Google Shape;569;g3dab19ec515_10_282"/>
+          <p:cNvPr id="577" name="Google Shape;577;g3dab19ec515_10_282"/>
           <p:cNvSpPr txBox="1"/>
           <p:nvPr/>
         </p:nvSpPr>
@@ -15539,7 +16803,7 @@
       </p:sp>
       <p:sp>
         <p:nvSpPr>
-          <p:cNvPr id="570" name="Google Shape;570;g3dab19ec515_10_282"/>
+          <p:cNvPr id="578" name="Google Shape;578;g3dab19ec515_10_282"/>
           <p:cNvSpPr/>
           <p:nvPr/>
         </p:nvSpPr>
@@ -15593,7 +16857,7 @@
       </p:sp>
       <p:sp>
         <p:nvSpPr>
-          <p:cNvPr id="571" name="Google Shape;571;g3dab19ec515_10_282"/>
+          <p:cNvPr id="579" name="Google Shape;579;g3dab19ec515_10_282"/>
           <p:cNvSpPr txBox="1"/>
           <p:nvPr/>
         </p:nvSpPr>
@@ -15709,7 +16973,7 @@
       </p:sp>
       <p:sp>
         <p:nvSpPr>
-          <p:cNvPr id="572" name="Google Shape;572;g3dab19ec515_10_282"/>
+          <p:cNvPr id="580" name="Google Shape;580;g3dab19ec515_10_282"/>
           <p:cNvSpPr/>
           <p:nvPr/>
         </p:nvSpPr>
@@ -15763,7 +17027,7 @@
       </p:sp>
       <p:sp>
         <p:nvSpPr>
-          <p:cNvPr id="573" name="Google Shape;573;g3dab19ec515_10_282"/>
+          <p:cNvPr id="581" name="Google Shape;581;g3dab19ec515_10_282"/>
           <p:cNvSpPr txBox="1"/>
           <p:nvPr/>
         </p:nvSpPr>
@@ -15879,7 +17143,7 @@
       </p:sp>
       <p:sp>
         <p:nvSpPr>
-          <p:cNvPr id="574" name="Google Shape;574;g3dab19ec515_10_282"/>
+          <p:cNvPr id="582" name="Google Shape;582;g3dab19ec515_10_282"/>
           <p:cNvSpPr/>
           <p:nvPr/>
         </p:nvSpPr>
@@ -15933,7 +17197,7 @@
       </p:sp>
       <p:sp>
         <p:nvSpPr>
-          <p:cNvPr id="575" name="Google Shape;575;g3dab19ec515_10_282"/>
+          <p:cNvPr id="583" name="Google Shape;583;g3dab19ec515_10_282"/>
           <p:cNvSpPr txBox="1"/>
           <p:nvPr/>
         </p:nvSpPr>
@@ -16049,7 +17313,7 @@
       </p:sp>
       <p:sp>
         <p:nvSpPr>
-          <p:cNvPr id="576" name="Google Shape;576;g3dab19ec515_10_282"/>
+          <p:cNvPr id="584" name="Google Shape;584;g3dab19ec515_10_282"/>
           <p:cNvSpPr/>
           <p:nvPr/>
         </p:nvSpPr>
@@ -16103,7 +17367,7 @@
       </p:sp>
       <p:sp>
         <p:nvSpPr>
-          <p:cNvPr id="577" name="Google Shape;577;g3dab19ec515_10_282"/>
+          <p:cNvPr id="585" name="Google Shape;585;g3dab19ec515_10_282"/>
           <p:cNvSpPr txBox="1"/>
           <p:nvPr/>
         </p:nvSpPr>
@@ -25795,7 +27059,7 @@
         <p:spPr>
           <a:xfrm>
             <a:off x="5216914" y="1969744"/>
-            <a:ext cx="1758000" cy="406500"/>
+            <a:ext cx="1758000" cy="184800"/>
           </a:xfrm>
           <a:prstGeom prst="rect">
             <a:avLst/>
@@ -25833,7 +27097,7 @@
                 <a:cs typeface="Calibri"/>
                 <a:sym typeface="Calibri"/>
               </a:rPr>
-              <a:t>up to 25 layers per encoder · 768-1024 dim</a:t>
+              <a:t>up to 25 layers per encoder </a:t>
             </a:r>
             <a:endParaRPr/>
           </a:p>
@@ -26497,7 +27761,7 @@
                 <a:cs typeface="Calibri"/>
                 <a:sym typeface="Calibri"/>
               </a:rPr>
-              <a:t>Acc, F1 (classification) · RMSE (V/A/D)</a:t>
+              <a:t>Acc, F1 (classification) · RMSE</a:t>
             </a:r>
             <a:endParaRPr/>
           </a:p>
@@ -26731,7 +27995,7 @@
         <p:spPr>
           <a:xfrm>
             <a:off x="457200" y="2632340"/>
-            <a:ext cx="7315200" cy="169200"/>
+            <a:ext cx="7315200" cy="184800"/>
           </a:xfrm>
           <a:prstGeom prst="rect">
             <a:avLst/>
@@ -26757,7 +28021,7 @@
               <a:buNone/>
             </a:pPr>
             <a:r>
-              <a:rPr b="1" i="0" lang="en-US" sz="1100" u="none" cap="none" strike="noStrike">
+              <a:rPr b="1" i="0" lang="en-US" sz="1200" u="none" cap="none" strike="noStrike">
                 <a:solidFill>
                   <a:schemeClr val="dk1"/>
                 </a:solidFill>
@@ -26769,7 +28033,7 @@
               <a:t>PROBING SETUPS</a:t>
             </a:r>
             <a:r>
-              <a:rPr b="1" i="0" lang="en-US" sz="1100" u="none" cap="none" strike="noStrike">
+              <a:rPr b="1" i="0" lang="en-US" sz="1200" u="none" cap="none" strike="noStrike">
                 <a:solidFill>
                   <a:schemeClr val="dk1"/>
                 </a:solidFill>
@@ -26781,7 +28045,7 @@
               <a:t>    </a:t>
             </a:r>
             <a:r>
-              <a:rPr b="1" i="1" lang="en-US" sz="1100" u="none" cap="none" strike="noStrike">
+              <a:rPr b="1" i="1" lang="en-US" sz="1200" u="none" cap="none" strike="noStrike">
                 <a:solidFill>
                   <a:schemeClr val="dk1"/>
                 </a:solidFill>
@@ -26792,7 +28056,7 @@
               </a:rPr>
               <a:t>what does each layer encode</a:t>
             </a:r>
-            <a:endParaRPr b="1" sz="1500">
+            <a:endParaRPr b="1" sz="1600">
               <a:solidFill>
                 <a:schemeClr val="dk1"/>
               </a:solidFill>
@@ -28067,7 +29331,7 @@
         <p:spPr>
           <a:xfrm>
             <a:off x="457200" y="3831336"/>
-            <a:ext cx="7315200" cy="169200"/>
+            <a:ext cx="7315200" cy="184800"/>
           </a:xfrm>
           <a:prstGeom prst="rect">
             <a:avLst/>
@@ -28093,7 +29357,7 @@
               <a:buNone/>
             </a:pPr>
             <a:r>
-              <a:rPr b="1" i="0" lang="en-US" sz="1100" u="none" cap="none" strike="noStrike">
+              <a:rPr b="1" i="0" lang="en-US" sz="1200" u="none" cap="none" strike="noStrike">
                 <a:solidFill>
                   <a:srgbClr val="C2550C"/>
                 </a:solidFill>
@@ -28105,7 +29369,7 @@
               <a:t>LINGUISTIC BIAS FALSIFICATION</a:t>
             </a:r>
             <a:r>
-              <a:rPr b="0" i="0" lang="en-US" sz="1100" u="none" cap="none" strike="noStrike">
+              <a:rPr b="0" i="0" lang="en-US" sz="1200" u="none" cap="none" strike="noStrike">
                 <a:solidFill>
                   <a:srgbClr val="8A92A3"/>
                 </a:solidFill>
@@ -28117,7 +29381,7 @@
               <a:t>    </a:t>
             </a:r>
             <a:r>
-              <a:rPr b="1" i="1" lang="en-US" sz="1100" u="none" cap="none" strike="noStrike">
+              <a:rPr b="1" i="1" lang="en-US" sz="1200" u="none" cap="none" strike="noStrike">
                 <a:solidFill>
                   <a:schemeClr val="dk1"/>
                 </a:solidFill>
@@ -28128,7 +29392,7 @@
               </a:rPr>
               <a:t>is the signal voice or words</a:t>
             </a:r>
-            <a:endParaRPr b="1" sz="1500">
+            <a:endParaRPr b="1" sz="1600">
               <a:solidFill>
                 <a:schemeClr val="dk1"/>
               </a:solidFill>

</xml_diff>